<commit_message>
Streamline of R codes and update of figures layout
</commit_message>
<xml_diff>
--- a/Output Figures/Intermediate Figures/editing figures.pptx
+++ b/Output Figures/Intermediate Figures/editing figures.pptx
@@ -2,22 +2,23 @@
 <file path=ppt/presentation.xml><?xml version="1.0" encoding="utf-8"?>
 <p:presentation xmlns:a="http://schemas.openxmlformats.org/drawingml/2006/main" xmlns:r="http://schemas.openxmlformats.org/officeDocument/2006/relationships" xmlns:p="http://schemas.openxmlformats.org/presentationml/2006/main" saveSubsetFonts="1">
   <p:sldMasterIdLst>
-    <p:sldMasterId id="2147483648" r:id="rId1"/>
+    <p:sldMasterId id="2147483660" r:id="rId1"/>
   </p:sldMasterIdLst>
   <p:sldIdLst>
     <p:sldId id="305" r:id="rId2"/>
     <p:sldId id="298" r:id="rId3"/>
     <p:sldId id="296" r:id="rId4"/>
     <p:sldId id="303" r:id="rId5"/>
-    <p:sldId id="295" r:id="rId6"/>
+    <p:sldId id="306" r:id="rId6"/>
+    <p:sldId id="295" r:id="rId7"/>
   </p:sldIdLst>
-  <p:sldSz cx="12192000" cy="6858000"/>
+  <p:sldSz cx="7772400" cy="10058400"/>
   <p:notesSz cx="6858000" cy="9144000"/>
   <p:defaultTextStyle>
     <a:defPPr>
       <a:defRPr lang="en-US"/>
     </a:defPPr>
-    <a:lvl1pPr marL="0" algn="l" defTabSz="914400" rtl="0" eaLnBrk="1" latinLnBrk="0" hangingPunct="1">
+    <a:lvl1pPr marL="0" algn="l" defTabSz="457200" rtl="0" eaLnBrk="1" latinLnBrk="0" hangingPunct="1">
       <a:defRPr sz="1800" kern="1200">
         <a:solidFill>
           <a:schemeClr val="tx1"/>
@@ -27,7 +28,7 @@
         <a:cs typeface="+mn-cs"/>
       </a:defRPr>
     </a:lvl1pPr>
-    <a:lvl2pPr marL="457200" algn="l" defTabSz="914400" rtl="0" eaLnBrk="1" latinLnBrk="0" hangingPunct="1">
+    <a:lvl2pPr marL="457200" algn="l" defTabSz="457200" rtl="0" eaLnBrk="1" latinLnBrk="0" hangingPunct="1">
       <a:defRPr sz="1800" kern="1200">
         <a:solidFill>
           <a:schemeClr val="tx1"/>
@@ -37,7 +38,7 @@
         <a:cs typeface="+mn-cs"/>
       </a:defRPr>
     </a:lvl2pPr>
-    <a:lvl3pPr marL="914400" algn="l" defTabSz="914400" rtl="0" eaLnBrk="1" latinLnBrk="0" hangingPunct="1">
+    <a:lvl3pPr marL="914400" algn="l" defTabSz="457200" rtl="0" eaLnBrk="1" latinLnBrk="0" hangingPunct="1">
       <a:defRPr sz="1800" kern="1200">
         <a:solidFill>
           <a:schemeClr val="tx1"/>
@@ -47,7 +48,7 @@
         <a:cs typeface="+mn-cs"/>
       </a:defRPr>
     </a:lvl3pPr>
-    <a:lvl4pPr marL="1371600" algn="l" defTabSz="914400" rtl="0" eaLnBrk="1" latinLnBrk="0" hangingPunct="1">
+    <a:lvl4pPr marL="1371600" algn="l" defTabSz="457200" rtl="0" eaLnBrk="1" latinLnBrk="0" hangingPunct="1">
       <a:defRPr sz="1800" kern="1200">
         <a:solidFill>
           <a:schemeClr val="tx1"/>
@@ -57,7 +58,7 @@
         <a:cs typeface="+mn-cs"/>
       </a:defRPr>
     </a:lvl4pPr>
-    <a:lvl5pPr marL="1828800" algn="l" defTabSz="914400" rtl="0" eaLnBrk="1" latinLnBrk="0" hangingPunct="1">
+    <a:lvl5pPr marL="1828800" algn="l" defTabSz="457200" rtl="0" eaLnBrk="1" latinLnBrk="0" hangingPunct="1">
       <a:defRPr sz="1800" kern="1200">
         <a:solidFill>
           <a:schemeClr val="tx1"/>
@@ -67,7 +68,7 @@
         <a:cs typeface="+mn-cs"/>
       </a:defRPr>
     </a:lvl5pPr>
-    <a:lvl6pPr marL="2286000" algn="l" defTabSz="914400" rtl="0" eaLnBrk="1" latinLnBrk="0" hangingPunct="1">
+    <a:lvl6pPr marL="2286000" algn="l" defTabSz="457200" rtl="0" eaLnBrk="1" latinLnBrk="0" hangingPunct="1">
       <a:defRPr sz="1800" kern="1200">
         <a:solidFill>
           <a:schemeClr val="tx1"/>
@@ -77,7 +78,7 @@
         <a:cs typeface="+mn-cs"/>
       </a:defRPr>
     </a:lvl6pPr>
-    <a:lvl7pPr marL="2743200" algn="l" defTabSz="914400" rtl="0" eaLnBrk="1" latinLnBrk="0" hangingPunct="1">
+    <a:lvl7pPr marL="2743200" algn="l" defTabSz="457200" rtl="0" eaLnBrk="1" latinLnBrk="0" hangingPunct="1">
       <a:defRPr sz="1800" kern="1200">
         <a:solidFill>
           <a:schemeClr val="tx1"/>
@@ -87,7 +88,7 @@
         <a:cs typeface="+mn-cs"/>
       </a:defRPr>
     </a:lvl7pPr>
-    <a:lvl8pPr marL="3200400" algn="l" defTabSz="914400" rtl="0" eaLnBrk="1" latinLnBrk="0" hangingPunct="1">
+    <a:lvl8pPr marL="3200400" algn="l" defTabSz="457200" rtl="0" eaLnBrk="1" latinLnBrk="0" hangingPunct="1">
       <a:defRPr sz="1800" kern="1200">
         <a:solidFill>
           <a:schemeClr val="tx1"/>
@@ -97,7 +98,7 @@
         <a:cs typeface="+mn-cs"/>
       </a:defRPr>
     </a:lvl8pPr>
-    <a:lvl9pPr marL="3657600" algn="l" defTabSz="914400" rtl="0" eaLnBrk="1" latinLnBrk="0" hangingPunct="1">
+    <a:lvl9pPr marL="3657600" algn="l" defTabSz="457200" rtl="0" eaLnBrk="1" latinLnBrk="0" hangingPunct="1">
       <a:defRPr sz="1800" kern="1200">
         <a:solidFill>
           <a:schemeClr val="tx1"/>
@@ -135,13 +136,7 @@
       </p:grpSpPr>
       <p:sp>
         <p:nvSpPr>
-          <p:cNvPr id="2" name="Title 1">
-            <a:extLst>
-              <a:ext uri="{FF2B5EF4-FFF2-40B4-BE49-F238E27FC236}">
-                <a16:creationId xmlns:a16="http://schemas.microsoft.com/office/drawing/2014/main" id="{C7A8A16B-A04B-D6E1-2ED3-174F01F47E86}"/>
-              </a:ext>
-            </a:extLst>
-          </p:cNvPr>
+          <p:cNvPr id="2" name="Title 1"/>
           <p:cNvSpPr>
             <a:spLocks noGrp="1"/>
           </p:cNvSpPr>
@@ -151,15 +146,15 @@
         </p:nvSpPr>
         <p:spPr>
           <a:xfrm>
-            <a:off x="1524000" y="1122363"/>
-            <a:ext cx="9144000" cy="2387600"/>
+            <a:off x="582930" y="1646133"/>
+            <a:ext cx="6606540" cy="3501813"/>
           </a:xfrm>
         </p:spPr>
         <p:txBody>
           <a:bodyPr anchor="b"/>
           <a:lstStyle>
             <a:lvl1pPr algn="ctr">
-              <a:defRPr sz="6000"/>
+              <a:defRPr sz="5100"/>
             </a:lvl1pPr>
           </a:lstStyle>
           <a:p>
@@ -167,18 +162,13 @@
               <a:rPr lang="en-US"/>
               <a:t>Click to edit Master title style</a:t>
             </a:r>
-          </a:p>
-        </p:txBody>
-      </p:sp>
-      <p:sp>
-        <p:nvSpPr>
-          <p:cNvPr id="3" name="Subtitle 2">
-            <a:extLst>
-              <a:ext uri="{FF2B5EF4-FFF2-40B4-BE49-F238E27FC236}">
-                <a16:creationId xmlns:a16="http://schemas.microsoft.com/office/drawing/2014/main" id="{BA9B7A9D-41B3-E2BE-AB3D-D9319AA0A030}"/>
-              </a:ext>
-            </a:extLst>
-          </p:cNvPr>
+            <a:endParaRPr lang="en-US" dirty="0"/>
+          </a:p>
+        </p:txBody>
+      </p:sp>
+      <p:sp>
+        <p:nvSpPr>
+          <p:cNvPr id="3" name="Subtitle 2"/>
           <p:cNvSpPr>
             <a:spLocks noGrp="1"/>
           </p:cNvSpPr>
@@ -188,8 +178,8 @@
         </p:nvSpPr>
         <p:spPr>
           <a:xfrm>
-            <a:off x="1524000" y="3602038"/>
-            <a:ext cx="9144000" cy="1655762"/>
+            <a:off x="971550" y="5282989"/>
+            <a:ext cx="5829300" cy="2428451"/>
           </a:xfrm>
         </p:spPr>
         <p:txBody>
@@ -197,39 +187,39 @@
           <a:lstStyle>
             <a:lvl1pPr marL="0" indent="0" algn="ctr">
               <a:buNone/>
-              <a:defRPr sz="2400"/>
+              <a:defRPr sz="2040"/>
             </a:lvl1pPr>
-            <a:lvl2pPr marL="457206" indent="0" algn="ctr">
-              <a:buNone/>
-              <a:defRPr sz="2000"/>
+            <a:lvl2pPr marL="388620" indent="0" algn="ctr">
+              <a:buNone/>
+              <a:defRPr sz="1700"/>
             </a:lvl2pPr>
-            <a:lvl3pPr marL="914411" indent="0" algn="ctr">
-              <a:buNone/>
-              <a:defRPr sz="1801"/>
+            <a:lvl3pPr marL="777240" indent="0" algn="ctr">
+              <a:buNone/>
+              <a:defRPr sz="1530"/>
             </a:lvl3pPr>
-            <a:lvl4pPr marL="1371617" indent="0" algn="ctr">
-              <a:buNone/>
-              <a:defRPr sz="1600"/>
+            <a:lvl4pPr marL="1165860" indent="0" algn="ctr">
+              <a:buNone/>
+              <a:defRPr sz="1360"/>
             </a:lvl4pPr>
-            <a:lvl5pPr marL="1828823" indent="0" algn="ctr">
-              <a:buNone/>
-              <a:defRPr sz="1600"/>
+            <a:lvl5pPr marL="1554480" indent="0" algn="ctr">
+              <a:buNone/>
+              <a:defRPr sz="1360"/>
             </a:lvl5pPr>
-            <a:lvl6pPr marL="2286029" indent="0" algn="ctr">
-              <a:buNone/>
-              <a:defRPr sz="1600"/>
+            <a:lvl6pPr marL="1943100" indent="0" algn="ctr">
+              <a:buNone/>
+              <a:defRPr sz="1360"/>
             </a:lvl6pPr>
-            <a:lvl7pPr marL="2743234" indent="0" algn="ctr">
-              <a:buNone/>
-              <a:defRPr sz="1600"/>
+            <a:lvl7pPr marL="2331720" indent="0" algn="ctr">
+              <a:buNone/>
+              <a:defRPr sz="1360"/>
             </a:lvl7pPr>
-            <a:lvl8pPr marL="3200440" indent="0" algn="ctr">
-              <a:buNone/>
-              <a:defRPr sz="1600"/>
+            <a:lvl8pPr marL="2720340" indent="0" algn="ctr">
+              <a:buNone/>
+              <a:defRPr sz="1360"/>
             </a:lvl8pPr>
-            <a:lvl9pPr marL="3657646" indent="0" algn="ctr">
-              <a:buNone/>
-              <a:defRPr sz="1600"/>
+            <a:lvl9pPr marL="3108960" indent="0" algn="ctr">
+              <a:buNone/>
+              <a:defRPr sz="1360"/>
             </a:lvl9pPr>
           </a:lstStyle>
           <a:p>
@@ -237,18 +227,13 @@
               <a:rPr lang="en-US"/>
               <a:t>Click to edit Master subtitle style</a:t>
             </a:r>
-          </a:p>
-        </p:txBody>
-      </p:sp>
-      <p:sp>
-        <p:nvSpPr>
-          <p:cNvPr id="4" name="Date Placeholder 3">
-            <a:extLst>
-              <a:ext uri="{FF2B5EF4-FFF2-40B4-BE49-F238E27FC236}">
-                <a16:creationId xmlns:a16="http://schemas.microsoft.com/office/drawing/2014/main" id="{9EF556A5-EF67-1EE2-4541-526779A27866}"/>
-              </a:ext>
-            </a:extLst>
-          </p:cNvPr>
+            <a:endParaRPr lang="en-US" dirty="0"/>
+          </a:p>
+        </p:txBody>
+      </p:sp>
+      <p:sp>
+        <p:nvSpPr>
+          <p:cNvPr id="4" name="Date Placeholder 3"/>
           <p:cNvSpPr>
             <a:spLocks noGrp="1"/>
           </p:cNvSpPr>
@@ -263,7 +248,7 @@
           <a:p>
             <a:fld id="{C99C87EC-6FA1-4B02-B2BA-F8C70409488A}" type="datetimeFigureOut">
               <a:rPr lang="en-US" smtClean="0"/>
-              <a:t>7/28/2026</a:t>
+              <a:t>8/12/2026</a:t>
             </a:fld>
             <a:endParaRPr lang="en-US"/>
           </a:p>
@@ -271,13 +256,7 @@
       </p:sp>
       <p:sp>
         <p:nvSpPr>
-          <p:cNvPr id="5" name="Footer Placeholder 4">
-            <a:extLst>
-              <a:ext uri="{FF2B5EF4-FFF2-40B4-BE49-F238E27FC236}">
-                <a16:creationId xmlns:a16="http://schemas.microsoft.com/office/drawing/2014/main" id="{79413F1E-510C-7D4A-191D-12023CE841B9}"/>
-              </a:ext>
-            </a:extLst>
-          </p:cNvPr>
+          <p:cNvPr id="5" name="Footer Placeholder 4"/>
           <p:cNvSpPr>
             <a:spLocks noGrp="1"/>
           </p:cNvSpPr>
@@ -296,13 +275,7 @@
       </p:sp>
       <p:sp>
         <p:nvSpPr>
-          <p:cNvPr id="6" name="Slide Number Placeholder 5">
-            <a:extLst>
-              <a:ext uri="{FF2B5EF4-FFF2-40B4-BE49-F238E27FC236}">
-                <a16:creationId xmlns:a16="http://schemas.microsoft.com/office/drawing/2014/main" id="{020E4A7F-9F59-0511-6CE4-65295F8290C9}"/>
-              </a:ext>
-            </a:extLst>
-          </p:cNvPr>
+          <p:cNvPr id="6" name="Slide Number Placeholder 5"/>
           <p:cNvSpPr>
             <a:spLocks noGrp="1"/>
           </p:cNvSpPr>
@@ -326,7 +299,7 @@
     </p:spTree>
     <p:extLst>
       <p:ext uri="{BB962C8B-B14F-4D97-AF65-F5344CB8AC3E}">
-        <p14:creationId xmlns:p14="http://schemas.microsoft.com/office/powerpoint/2010/main" val="4290031425"/>
+        <p14:creationId xmlns:p14="http://schemas.microsoft.com/office/powerpoint/2010/main" val="463516860"/>
       </p:ext>
     </p:extLst>
   </p:cSld>
@@ -355,13 +328,7 @@
       </p:grpSpPr>
       <p:sp>
         <p:nvSpPr>
-          <p:cNvPr id="2" name="Title 1">
-            <a:extLst>
-              <a:ext uri="{FF2B5EF4-FFF2-40B4-BE49-F238E27FC236}">
-                <a16:creationId xmlns:a16="http://schemas.microsoft.com/office/drawing/2014/main" id="{B4C35A58-5986-0CAB-7938-11C43560B138}"/>
-              </a:ext>
-            </a:extLst>
-          </p:cNvPr>
+          <p:cNvPr id="2" name="Title 1"/>
           <p:cNvSpPr>
             <a:spLocks noGrp="1"/>
           </p:cNvSpPr>
@@ -378,18 +345,13 @@
               <a:rPr lang="en-US"/>
               <a:t>Click to edit Master title style</a:t>
             </a:r>
-          </a:p>
-        </p:txBody>
-      </p:sp>
-      <p:sp>
-        <p:nvSpPr>
-          <p:cNvPr id="3" name="Vertical Text Placeholder 2">
-            <a:extLst>
-              <a:ext uri="{FF2B5EF4-FFF2-40B4-BE49-F238E27FC236}">
-                <a16:creationId xmlns:a16="http://schemas.microsoft.com/office/drawing/2014/main" id="{F7453D86-B230-DCC9-91AB-9DE5ECCA81C1}"/>
-              </a:ext>
-            </a:extLst>
-          </p:cNvPr>
+            <a:endParaRPr lang="en-US" dirty="0"/>
+          </a:p>
+        </p:txBody>
+      </p:sp>
+      <p:sp>
+        <p:nvSpPr>
+          <p:cNvPr id="3" name="Vertical Text Placeholder 2"/>
           <p:cNvSpPr>
             <a:spLocks noGrp="1"/>
           </p:cNvSpPr>
@@ -435,18 +397,13 @@
               <a:rPr lang="en-US"/>
               <a:t>Fifth level</a:t>
             </a:r>
-          </a:p>
-        </p:txBody>
-      </p:sp>
-      <p:sp>
-        <p:nvSpPr>
-          <p:cNvPr id="4" name="Date Placeholder 3">
-            <a:extLst>
-              <a:ext uri="{FF2B5EF4-FFF2-40B4-BE49-F238E27FC236}">
-                <a16:creationId xmlns:a16="http://schemas.microsoft.com/office/drawing/2014/main" id="{D0B85535-29CE-565E-9517-585CB9555F06}"/>
-              </a:ext>
-            </a:extLst>
-          </p:cNvPr>
+            <a:endParaRPr lang="en-US" dirty="0"/>
+          </a:p>
+        </p:txBody>
+      </p:sp>
+      <p:sp>
+        <p:nvSpPr>
+          <p:cNvPr id="4" name="Date Placeholder 3"/>
           <p:cNvSpPr>
             <a:spLocks noGrp="1"/>
           </p:cNvSpPr>
@@ -461,7 +418,7 @@
           <a:p>
             <a:fld id="{C99C87EC-6FA1-4B02-B2BA-F8C70409488A}" type="datetimeFigureOut">
               <a:rPr lang="en-US" smtClean="0"/>
-              <a:t>7/28/2026</a:t>
+              <a:t>8/12/2026</a:t>
             </a:fld>
             <a:endParaRPr lang="en-US"/>
           </a:p>
@@ -469,13 +426,7 @@
       </p:sp>
       <p:sp>
         <p:nvSpPr>
-          <p:cNvPr id="5" name="Footer Placeholder 4">
-            <a:extLst>
-              <a:ext uri="{FF2B5EF4-FFF2-40B4-BE49-F238E27FC236}">
-                <a16:creationId xmlns:a16="http://schemas.microsoft.com/office/drawing/2014/main" id="{10457DD1-DEE9-D856-D805-71A4984199E6}"/>
-              </a:ext>
-            </a:extLst>
-          </p:cNvPr>
+          <p:cNvPr id="5" name="Footer Placeholder 4"/>
           <p:cNvSpPr>
             <a:spLocks noGrp="1"/>
           </p:cNvSpPr>
@@ -494,13 +445,7 @@
       </p:sp>
       <p:sp>
         <p:nvSpPr>
-          <p:cNvPr id="6" name="Slide Number Placeholder 5">
-            <a:extLst>
-              <a:ext uri="{FF2B5EF4-FFF2-40B4-BE49-F238E27FC236}">
-                <a16:creationId xmlns:a16="http://schemas.microsoft.com/office/drawing/2014/main" id="{50723219-15A0-F981-BD1E-E010B45922C5}"/>
-              </a:ext>
-            </a:extLst>
-          </p:cNvPr>
+          <p:cNvPr id="6" name="Slide Number Placeholder 5"/>
           <p:cNvSpPr>
             <a:spLocks noGrp="1"/>
           </p:cNvSpPr>
@@ -524,7 +469,7 @@
     </p:spTree>
     <p:extLst>
       <p:ext uri="{BB962C8B-B14F-4D97-AF65-F5344CB8AC3E}">
-        <p14:creationId xmlns:p14="http://schemas.microsoft.com/office/powerpoint/2010/main" val="2406132309"/>
+        <p14:creationId xmlns:p14="http://schemas.microsoft.com/office/powerpoint/2010/main" val="4292635723"/>
       </p:ext>
     </p:extLst>
   </p:cSld>
@@ -553,13 +498,7 @@
       </p:grpSpPr>
       <p:sp>
         <p:nvSpPr>
-          <p:cNvPr id="2" name="Vertical Title 1">
-            <a:extLst>
-              <a:ext uri="{FF2B5EF4-FFF2-40B4-BE49-F238E27FC236}">
-                <a16:creationId xmlns:a16="http://schemas.microsoft.com/office/drawing/2014/main" id="{76E1CE2D-ABB4-73A5-26EB-F3DCAFAED308}"/>
-              </a:ext>
-            </a:extLst>
-          </p:cNvPr>
+          <p:cNvPr id="2" name="Vertical Title 1"/>
           <p:cNvSpPr>
             <a:spLocks noGrp="1"/>
           </p:cNvSpPr>
@@ -569,8 +508,8 @@
         </p:nvSpPr>
         <p:spPr>
           <a:xfrm>
-            <a:off x="8724899" y="365125"/>
-            <a:ext cx="2628900" cy="5811838"/>
+            <a:off x="5562124" y="535517"/>
+            <a:ext cx="1675924" cy="8524029"/>
           </a:xfrm>
         </p:spPr>
         <p:txBody>
@@ -581,18 +520,13 @@
               <a:rPr lang="en-US"/>
               <a:t>Click to edit Master title style</a:t>
             </a:r>
-          </a:p>
-        </p:txBody>
-      </p:sp>
-      <p:sp>
-        <p:nvSpPr>
-          <p:cNvPr id="3" name="Vertical Text Placeholder 2">
-            <a:extLst>
-              <a:ext uri="{FF2B5EF4-FFF2-40B4-BE49-F238E27FC236}">
-                <a16:creationId xmlns:a16="http://schemas.microsoft.com/office/drawing/2014/main" id="{40467FEB-C94F-8F69-7DE1-7A32BA474637}"/>
-              </a:ext>
-            </a:extLst>
-          </p:cNvPr>
+            <a:endParaRPr lang="en-US" dirty="0"/>
+          </a:p>
+        </p:txBody>
+      </p:sp>
+      <p:sp>
+        <p:nvSpPr>
+          <p:cNvPr id="3" name="Vertical Text Placeholder 2"/>
           <p:cNvSpPr>
             <a:spLocks noGrp="1"/>
           </p:cNvSpPr>
@@ -602,8 +536,8 @@
         </p:nvSpPr>
         <p:spPr>
           <a:xfrm>
-            <a:off x="838199" y="365125"/>
-            <a:ext cx="7734300" cy="5811838"/>
+            <a:off x="534353" y="535517"/>
+            <a:ext cx="4930616" cy="8524029"/>
           </a:xfrm>
         </p:spPr>
         <p:txBody>
@@ -643,18 +577,13 @@
               <a:rPr lang="en-US"/>
               <a:t>Fifth level</a:t>
             </a:r>
-          </a:p>
-        </p:txBody>
-      </p:sp>
-      <p:sp>
-        <p:nvSpPr>
-          <p:cNvPr id="4" name="Date Placeholder 3">
-            <a:extLst>
-              <a:ext uri="{FF2B5EF4-FFF2-40B4-BE49-F238E27FC236}">
-                <a16:creationId xmlns:a16="http://schemas.microsoft.com/office/drawing/2014/main" id="{51D56F5F-DF8E-164D-EF2B-8576672A3739}"/>
-              </a:ext>
-            </a:extLst>
-          </p:cNvPr>
+            <a:endParaRPr lang="en-US" dirty="0"/>
+          </a:p>
+        </p:txBody>
+      </p:sp>
+      <p:sp>
+        <p:nvSpPr>
+          <p:cNvPr id="4" name="Date Placeholder 3"/>
           <p:cNvSpPr>
             <a:spLocks noGrp="1"/>
           </p:cNvSpPr>
@@ -669,7 +598,7 @@
           <a:p>
             <a:fld id="{C99C87EC-6FA1-4B02-B2BA-F8C70409488A}" type="datetimeFigureOut">
               <a:rPr lang="en-US" smtClean="0"/>
-              <a:t>7/28/2026</a:t>
+              <a:t>8/12/2026</a:t>
             </a:fld>
             <a:endParaRPr lang="en-US"/>
           </a:p>
@@ -677,13 +606,7 @@
       </p:sp>
       <p:sp>
         <p:nvSpPr>
-          <p:cNvPr id="5" name="Footer Placeholder 4">
-            <a:extLst>
-              <a:ext uri="{FF2B5EF4-FFF2-40B4-BE49-F238E27FC236}">
-                <a16:creationId xmlns:a16="http://schemas.microsoft.com/office/drawing/2014/main" id="{C745C1FB-9C81-0834-B00A-11B819DA4FD1}"/>
-              </a:ext>
-            </a:extLst>
-          </p:cNvPr>
+          <p:cNvPr id="5" name="Footer Placeholder 4"/>
           <p:cNvSpPr>
             <a:spLocks noGrp="1"/>
           </p:cNvSpPr>
@@ -702,13 +625,7 @@
       </p:sp>
       <p:sp>
         <p:nvSpPr>
-          <p:cNvPr id="6" name="Slide Number Placeholder 5">
-            <a:extLst>
-              <a:ext uri="{FF2B5EF4-FFF2-40B4-BE49-F238E27FC236}">
-                <a16:creationId xmlns:a16="http://schemas.microsoft.com/office/drawing/2014/main" id="{4BE463A3-F6A1-1796-D25D-BF73B1C55396}"/>
-              </a:ext>
-            </a:extLst>
-          </p:cNvPr>
+          <p:cNvPr id="6" name="Slide Number Placeholder 5"/>
           <p:cNvSpPr>
             <a:spLocks noGrp="1"/>
           </p:cNvSpPr>
@@ -732,7 +649,7 @@
     </p:spTree>
     <p:extLst>
       <p:ext uri="{BB962C8B-B14F-4D97-AF65-F5344CB8AC3E}">
-        <p14:creationId xmlns:p14="http://schemas.microsoft.com/office/powerpoint/2010/main" val="3946015236"/>
+        <p14:creationId xmlns:p14="http://schemas.microsoft.com/office/powerpoint/2010/main" val="1846430600"/>
       </p:ext>
     </p:extLst>
   </p:cSld>
@@ -761,13 +678,7 @@
       </p:grpSpPr>
       <p:sp>
         <p:nvSpPr>
-          <p:cNvPr id="2" name="Title 1">
-            <a:extLst>
-              <a:ext uri="{FF2B5EF4-FFF2-40B4-BE49-F238E27FC236}">
-                <a16:creationId xmlns:a16="http://schemas.microsoft.com/office/drawing/2014/main" id="{6380BFA8-A42E-C5C6-07ED-FA09AE279996}"/>
-              </a:ext>
-            </a:extLst>
-          </p:cNvPr>
+          <p:cNvPr id="2" name="Title 1"/>
           <p:cNvSpPr>
             <a:spLocks noGrp="1"/>
           </p:cNvSpPr>
@@ -784,18 +695,13 @@
               <a:rPr lang="en-US"/>
               <a:t>Click to edit Master title style</a:t>
             </a:r>
-          </a:p>
-        </p:txBody>
-      </p:sp>
-      <p:sp>
-        <p:nvSpPr>
-          <p:cNvPr id="3" name="Content Placeholder 2">
-            <a:extLst>
-              <a:ext uri="{FF2B5EF4-FFF2-40B4-BE49-F238E27FC236}">
-                <a16:creationId xmlns:a16="http://schemas.microsoft.com/office/drawing/2014/main" id="{3D3FFCFE-C2E8-CB64-011F-C3DB453D5B5E}"/>
-              </a:ext>
-            </a:extLst>
-          </p:cNvPr>
+            <a:endParaRPr lang="en-US" dirty="0"/>
+          </a:p>
+        </p:txBody>
+      </p:sp>
+      <p:sp>
+        <p:nvSpPr>
+          <p:cNvPr id="3" name="Content Placeholder 2"/>
           <p:cNvSpPr>
             <a:spLocks noGrp="1"/>
           </p:cNvSpPr>
@@ -841,18 +747,13 @@
               <a:rPr lang="en-US"/>
               <a:t>Fifth level</a:t>
             </a:r>
-          </a:p>
-        </p:txBody>
-      </p:sp>
-      <p:sp>
-        <p:nvSpPr>
-          <p:cNvPr id="4" name="Date Placeholder 3">
-            <a:extLst>
-              <a:ext uri="{FF2B5EF4-FFF2-40B4-BE49-F238E27FC236}">
-                <a16:creationId xmlns:a16="http://schemas.microsoft.com/office/drawing/2014/main" id="{FB80B0B0-EEEE-84C7-56D3-E3B576A5EA61}"/>
-              </a:ext>
-            </a:extLst>
-          </p:cNvPr>
+            <a:endParaRPr lang="en-US" dirty="0"/>
+          </a:p>
+        </p:txBody>
+      </p:sp>
+      <p:sp>
+        <p:nvSpPr>
+          <p:cNvPr id="4" name="Date Placeholder 3"/>
           <p:cNvSpPr>
             <a:spLocks noGrp="1"/>
           </p:cNvSpPr>
@@ -867,7 +768,7 @@
           <a:p>
             <a:fld id="{C99C87EC-6FA1-4B02-B2BA-F8C70409488A}" type="datetimeFigureOut">
               <a:rPr lang="en-US" smtClean="0"/>
-              <a:t>7/28/2026</a:t>
+              <a:t>8/12/2026</a:t>
             </a:fld>
             <a:endParaRPr lang="en-US"/>
           </a:p>
@@ -875,13 +776,7 @@
       </p:sp>
       <p:sp>
         <p:nvSpPr>
-          <p:cNvPr id="5" name="Footer Placeholder 4">
-            <a:extLst>
-              <a:ext uri="{FF2B5EF4-FFF2-40B4-BE49-F238E27FC236}">
-                <a16:creationId xmlns:a16="http://schemas.microsoft.com/office/drawing/2014/main" id="{C313BCA0-F3B9-0B33-5777-7CFAA3D15403}"/>
-              </a:ext>
-            </a:extLst>
-          </p:cNvPr>
+          <p:cNvPr id="5" name="Footer Placeholder 4"/>
           <p:cNvSpPr>
             <a:spLocks noGrp="1"/>
           </p:cNvSpPr>
@@ -900,13 +795,7 @@
       </p:sp>
       <p:sp>
         <p:nvSpPr>
-          <p:cNvPr id="6" name="Slide Number Placeholder 5">
-            <a:extLst>
-              <a:ext uri="{FF2B5EF4-FFF2-40B4-BE49-F238E27FC236}">
-                <a16:creationId xmlns:a16="http://schemas.microsoft.com/office/drawing/2014/main" id="{4B837B81-06A3-F2A5-CF78-693A3CEA653A}"/>
-              </a:ext>
-            </a:extLst>
-          </p:cNvPr>
+          <p:cNvPr id="6" name="Slide Number Placeholder 5"/>
           <p:cNvSpPr>
             <a:spLocks noGrp="1"/>
           </p:cNvSpPr>
@@ -930,7 +819,7 @@
     </p:spTree>
     <p:extLst>
       <p:ext uri="{BB962C8B-B14F-4D97-AF65-F5344CB8AC3E}">
-        <p14:creationId xmlns:p14="http://schemas.microsoft.com/office/powerpoint/2010/main" val="2363822203"/>
+        <p14:creationId xmlns:p14="http://schemas.microsoft.com/office/powerpoint/2010/main" val="771843695"/>
       </p:ext>
     </p:extLst>
   </p:cSld>
@@ -959,13 +848,7 @@
       </p:grpSpPr>
       <p:sp>
         <p:nvSpPr>
-          <p:cNvPr id="2" name="Title 1">
-            <a:extLst>
-              <a:ext uri="{FF2B5EF4-FFF2-40B4-BE49-F238E27FC236}">
-                <a16:creationId xmlns:a16="http://schemas.microsoft.com/office/drawing/2014/main" id="{C3D17980-7E7E-D35F-CEB9-209B55AEFDA9}"/>
-              </a:ext>
-            </a:extLst>
-          </p:cNvPr>
+          <p:cNvPr id="2" name="Title 1"/>
           <p:cNvSpPr>
             <a:spLocks noGrp="1"/>
           </p:cNvSpPr>
@@ -975,15 +858,15 @@
         </p:nvSpPr>
         <p:spPr>
           <a:xfrm>
-            <a:off x="831852" y="1709738"/>
-            <a:ext cx="10515600" cy="2852737"/>
+            <a:off x="530305" y="2507618"/>
+            <a:ext cx="6703695" cy="4184014"/>
           </a:xfrm>
         </p:spPr>
         <p:txBody>
           <a:bodyPr anchor="b"/>
           <a:lstStyle>
             <a:lvl1pPr>
-              <a:defRPr sz="6000"/>
+              <a:defRPr sz="5100"/>
             </a:lvl1pPr>
           </a:lstStyle>
           <a:p>
@@ -991,18 +874,13 @@
               <a:rPr lang="en-US"/>
               <a:t>Click to edit Master title style</a:t>
             </a:r>
-          </a:p>
-        </p:txBody>
-      </p:sp>
-      <p:sp>
-        <p:nvSpPr>
-          <p:cNvPr id="3" name="Text Placeholder 2">
-            <a:extLst>
-              <a:ext uri="{FF2B5EF4-FFF2-40B4-BE49-F238E27FC236}">
-                <a16:creationId xmlns:a16="http://schemas.microsoft.com/office/drawing/2014/main" id="{81082A81-1D7D-A323-4899-4799876D48E2}"/>
-              </a:ext>
-            </a:extLst>
-          </p:cNvPr>
+            <a:endParaRPr lang="en-US" dirty="0"/>
+          </a:p>
+        </p:txBody>
+      </p:sp>
+      <p:sp>
+        <p:nvSpPr>
+          <p:cNvPr id="3" name="Text Placeholder 2"/>
           <p:cNvSpPr>
             <a:spLocks noGrp="1"/>
           </p:cNvSpPr>
@@ -1012,8 +890,8 @@
         </p:nvSpPr>
         <p:spPr>
           <a:xfrm>
-            <a:off x="831852" y="4589464"/>
-            <a:ext cx="10515600" cy="1500187"/>
+            <a:off x="530305" y="6731215"/>
+            <a:ext cx="6703695" cy="2200274"/>
           </a:xfrm>
         </p:spPr>
         <p:txBody>
@@ -1021,7 +899,7 @@
           <a:lstStyle>
             <a:lvl1pPr marL="0" indent="0">
               <a:buNone/>
-              <a:defRPr sz="2400">
+              <a:defRPr sz="2040">
                 <a:solidFill>
                   <a:schemeClr val="tx1">
                     <a:tint val="82000"/>
@@ -1029,9 +907,9 @@
                 </a:solidFill>
               </a:defRPr>
             </a:lvl1pPr>
-            <a:lvl2pPr marL="457206" indent="0">
-              <a:buNone/>
-              <a:defRPr sz="2000">
+            <a:lvl2pPr marL="388620" indent="0">
+              <a:buNone/>
+              <a:defRPr sz="1700">
                 <a:solidFill>
                   <a:schemeClr val="tx1">
                     <a:tint val="82000"/>
@@ -1039,9 +917,9 @@
                 </a:solidFill>
               </a:defRPr>
             </a:lvl2pPr>
-            <a:lvl3pPr marL="914411" indent="0">
-              <a:buNone/>
-              <a:defRPr sz="1801">
+            <a:lvl3pPr marL="777240" indent="0">
+              <a:buNone/>
+              <a:defRPr sz="1530">
                 <a:solidFill>
                   <a:schemeClr val="tx1">
                     <a:tint val="82000"/>
@@ -1049,9 +927,9 @@
                 </a:solidFill>
               </a:defRPr>
             </a:lvl3pPr>
-            <a:lvl4pPr marL="1371617" indent="0">
-              <a:buNone/>
-              <a:defRPr sz="1600">
+            <a:lvl4pPr marL="1165860" indent="0">
+              <a:buNone/>
+              <a:defRPr sz="1360">
                 <a:solidFill>
                   <a:schemeClr val="tx1">
                     <a:tint val="82000"/>
@@ -1059,9 +937,9 @@
                 </a:solidFill>
               </a:defRPr>
             </a:lvl4pPr>
-            <a:lvl5pPr marL="1828823" indent="0">
-              <a:buNone/>
-              <a:defRPr sz="1600">
+            <a:lvl5pPr marL="1554480" indent="0">
+              <a:buNone/>
+              <a:defRPr sz="1360">
                 <a:solidFill>
                   <a:schemeClr val="tx1">
                     <a:tint val="82000"/>
@@ -1069,9 +947,9 @@
                 </a:solidFill>
               </a:defRPr>
             </a:lvl5pPr>
-            <a:lvl6pPr marL="2286029" indent="0">
-              <a:buNone/>
-              <a:defRPr sz="1600">
+            <a:lvl6pPr marL="1943100" indent="0">
+              <a:buNone/>
+              <a:defRPr sz="1360">
                 <a:solidFill>
                   <a:schemeClr val="tx1">
                     <a:tint val="82000"/>
@@ -1079,9 +957,9 @@
                 </a:solidFill>
               </a:defRPr>
             </a:lvl6pPr>
-            <a:lvl7pPr marL="2743234" indent="0">
-              <a:buNone/>
-              <a:defRPr sz="1600">
+            <a:lvl7pPr marL="2331720" indent="0">
+              <a:buNone/>
+              <a:defRPr sz="1360">
                 <a:solidFill>
                   <a:schemeClr val="tx1">
                     <a:tint val="82000"/>
@@ -1089,9 +967,9 @@
                 </a:solidFill>
               </a:defRPr>
             </a:lvl7pPr>
-            <a:lvl8pPr marL="3200440" indent="0">
-              <a:buNone/>
-              <a:defRPr sz="1600">
+            <a:lvl8pPr marL="2720340" indent="0">
+              <a:buNone/>
+              <a:defRPr sz="1360">
                 <a:solidFill>
                   <a:schemeClr val="tx1">
                     <a:tint val="82000"/>
@@ -1099,9 +977,9 @@
                 </a:solidFill>
               </a:defRPr>
             </a:lvl8pPr>
-            <a:lvl9pPr marL="3657646" indent="0">
-              <a:buNone/>
-              <a:defRPr sz="1600">
+            <a:lvl9pPr marL="3108960" indent="0">
+              <a:buNone/>
+              <a:defRPr sz="1360">
                 <a:solidFill>
                   <a:schemeClr val="tx1">
                     <a:tint val="82000"/>
@@ -1121,13 +999,7 @@
       </p:sp>
       <p:sp>
         <p:nvSpPr>
-          <p:cNvPr id="4" name="Date Placeholder 3">
-            <a:extLst>
-              <a:ext uri="{FF2B5EF4-FFF2-40B4-BE49-F238E27FC236}">
-                <a16:creationId xmlns:a16="http://schemas.microsoft.com/office/drawing/2014/main" id="{FC9A4F98-F8B2-73E8-3D44-763B1852C5AB}"/>
-              </a:ext>
-            </a:extLst>
-          </p:cNvPr>
+          <p:cNvPr id="4" name="Date Placeholder 3"/>
           <p:cNvSpPr>
             <a:spLocks noGrp="1"/>
           </p:cNvSpPr>
@@ -1142,7 +1014,7 @@
           <a:p>
             <a:fld id="{C99C87EC-6FA1-4B02-B2BA-F8C70409488A}" type="datetimeFigureOut">
               <a:rPr lang="en-US" smtClean="0"/>
-              <a:t>7/28/2026</a:t>
+              <a:t>8/12/2026</a:t>
             </a:fld>
             <a:endParaRPr lang="en-US"/>
           </a:p>
@@ -1150,13 +1022,7 @@
       </p:sp>
       <p:sp>
         <p:nvSpPr>
-          <p:cNvPr id="5" name="Footer Placeholder 4">
-            <a:extLst>
-              <a:ext uri="{FF2B5EF4-FFF2-40B4-BE49-F238E27FC236}">
-                <a16:creationId xmlns:a16="http://schemas.microsoft.com/office/drawing/2014/main" id="{7E1F137B-98ED-6BB6-8178-254E3376BAD4}"/>
-              </a:ext>
-            </a:extLst>
-          </p:cNvPr>
+          <p:cNvPr id="5" name="Footer Placeholder 4"/>
           <p:cNvSpPr>
             <a:spLocks noGrp="1"/>
           </p:cNvSpPr>
@@ -1175,13 +1041,7 @@
       </p:sp>
       <p:sp>
         <p:nvSpPr>
-          <p:cNvPr id="6" name="Slide Number Placeholder 5">
-            <a:extLst>
-              <a:ext uri="{FF2B5EF4-FFF2-40B4-BE49-F238E27FC236}">
-                <a16:creationId xmlns:a16="http://schemas.microsoft.com/office/drawing/2014/main" id="{EF583ACD-306E-71B7-1E02-8B24E259CDEE}"/>
-              </a:ext>
-            </a:extLst>
-          </p:cNvPr>
+          <p:cNvPr id="6" name="Slide Number Placeholder 5"/>
           <p:cNvSpPr>
             <a:spLocks noGrp="1"/>
           </p:cNvSpPr>
@@ -1205,7 +1065,7 @@
     </p:spTree>
     <p:extLst>
       <p:ext uri="{BB962C8B-B14F-4D97-AF65-F5344CB8AC3E}">
-        <p14:creationId xmlns:p14="http://schemas.microsoft.com/office/powerpoint/2010/main" val="1462598335"/>
+        <p14:creationId xmlns:p14="http://schemas.microsoft.com/office/powerpoint/2010/main" val="2447019810"/>
       </p:ext>
     </p:extLst>
   </p:cSld>
@@ -1234,13 +1094,7 @@
       </p:grpSpPr>
       <p:sp>
         <p:nvSpPr>
-          <p:cNvPr id="2" name="Title 1">
-            <a:extLst>
-              <a:ext uri="{FF2B5EF4-FFF2-40B4-BE49-F238E27FC236}">
-                <a16:creationId xmlns:a16="http://schemas.microsoft.com/office/drawing/2014/main" id="{85538DD4-607A-5603-8911-FB7EB2565315}"/>
-              </a:ext>
-            </a:extLst>
-          </p:cNvPr>
+          <p:cNvPr id="2" name="Title 1"/>
           <p:cNvSpPr>
             <a:spLocks noGrp="1"/>
           </p:cNvSpPr>
@@ -1257,18 +1111,13 @@
               <a:rPr lang="en-US"/>
               <a:t>Click to edit Master title style</a:t>
             </a:r>
-          </a:p>
-        </p:txBody>
-      </p:sp>
-      <p:sp>
-        <p:nvSpPr>
-          <p:cNvPr id="3" name="Content Placeholder 2">
-            <a:extLst>
-              <a:ext uri="{FF2B5EF4-FFF2-40B4-BE49-F238E27FC236}">
-                <a16:creationId xmlns:a16="http://schemas.microsoft.com/office/drawing/2014/main" id="{ACA99F0F-65BA-244C-F8A8-2242C5DCA1B9}"/>
-              </a:ext>
-            </a:extLst>
-          </p:cNvPr>
+            <a:endParaRPr lang="en-US" dirty="0"/>
+          </a:p>
+        </p:txBody>
+      </p:sp>
+      <p:sp>
+        <p:nvSpPr>
+          <p:cNvPr id="3" name="Content Placeholder 2"/>
           <p:cNvSpPr>
             <a:spLocks noGrp="1"/>
           </p:cNvSpPr>
@@ -1278,8 +1127,8 @@
         </p:nvSpPr>
         <p:spPr>
           <a:xfrm>
-            <a:off x="838201" y="1825625"/>
-            <a:ext cx="5181600" cy="4351338"/>
+            <a:off x="534353" y="2677584"/>
+            <a:ext cx="3303270" cy="6381962"/>
           </a:xfrm>
         </p:spPr>
         <p:txBody>
@@ -1319,18 +1168,13 @@
               <a:rPr lang="en-US"/>
               <a:t>Fifth level</a:t>
             </a:r>
-          </a:p>
-        </p:txBody>
-      </p:sp>
-      <p:sp>
-        <p:nvSpPr>
-          <p:cNvPr id="4" name="Content Placeholder 3">
-            <a:extLst>
-              <a:ext uri="{FF2B5EF4-FFF2-40B4-BE49-F238E27FC236}">
-                <a16:creationId xmlns:a16="http://schemas.microsoft.com/office/drawing/2014/main" id="{8D4465A2-C5BC-B04B-8768-3EE2A3DC1AC5}"/>
-              </a:ext>
-            </a:extLst>
-          </p:cNvPr>
+            <a:endParaRPr lang="en-US" dirty="0"/>
+          </a:p>
+        </p:txBody>
+      </p:sp>
+      <p:sp>
+        <p:nvSpPr>
+          <p:cNvPr id="4" name="Content Placeholder 3"/>
           <p:cNvSpPr>
             <a:spLocks noGrp="1"/>
           </p:cNvSpPr>
@@ -1340,8 +1184,8 @@
         </p:nvSpPr>
         <p:spPr>
           <a:xfrm>
-            <a:off x="6172201" y="1825625"/>
-            <a:ext cx="5181600" cy="4351338"/>
+            <a:off x="3934778" y="2677584"/>
+            <a:ext cx="3303270" cy="6381962"/>
           </a:xfrm>
         </p:spPr>
         <p:txBody>
@@ -1381,18 +1225,13 @@
               <a:rPr lang="en-US"/>
               <a:t>Fifth level</a:t>
             </a:r>
-          </a:p>
-        </p:txBody>
-      </p:sp>
-      <p:sp>
-        <p:nvSpPr>
-          <p:cNvPr id="5" name="Date Placeholder 4">
-            <a:extLst>
-              <a:ext uri="{FF2B5EF4-FFF2-40B4-BE49-F238E27FC236}">
-                <a16:creationId xmlns:a16="http://schemas.microsoft.com/office/drawing/2014/main" id="{22904783-A3EF-CFAD-D334-368D09913FA9}"/>
-              </a:ext>
-            </a:extLst>
-          </p:cNvPr>
+            <a:endParaRPr lang="en-US" dirty="0"/>
+          </a:p>
+        </p:txBody>
+      </p:sp>
+      <p:sp>
+        <p:nvSpPr>
+          <p:cNvPr id="5" name="Date Placeholder 4"/>
           <p:cNvSpPr>
             <a:spLocks noGrp="1"/>
           </p:cNvSpPr>
@@ -1407,7 +1246,7 @@
           <a:p>
             <a:fld id="{C99C87EC-6FA1-4B02-B2BA-F8C70409488A}" type="datetimeFigureOut">
               <a:rPr lang="en-US" smtClean="0"/>
-              <a:t>7/28/2026</a:t>
+              <a:t>8/12/2026</a:t>
             </a:fld>
             <a:endParaRPr lang="en-US"/>
           </a:p>
@@ -1415,13 +1254,7 @@
       </p:sp>
       <p:sp>
         <p:nvSpPr>
-          <p:cNvPr id="6" name="Footer Placeholder 5">
-            <a:extLst>
-              <a:ext uri="{FF2B5EF4-FFF2-40B4-BE49-F238E27FC236}">
-                <a16:creationId xmlns:a16="http://schemas.microsoft.com/office/drawing/2014/main" id="{078BC91C-3C39-5B88-D6DA-49F4C7A44A6A}"/>
-              </a:ext>
-            </a:extLst>
-          </p:cNvPr>
+          <p:cNvPr id="6" name="Footer Placeholder 5"/>
           <p:cNvSpPr>
             <a:spLocks noGrp="1"/>
           </p:cNvSpPr>
@@ -1440,13 +1273,7 @@
       </p:sp>
       <p:sp>
         <p:nvSpPr>
-          <p:cNvPr id="7" name="Slide Number Placeholder 6">
-            <a:extLst>
-              <a:ext uri="{FF2B5EF4-FFF2-40B4-BE49-F238E27FC236}">
-                <a16:creationId xmlns:a16="http://schemas.microsoft.com/office/drawing/2014/main" id="{36929881-8E42-C6DE-9E81-23A1BD792E41}"/>
-              </a:ext>
-            </a:extLst>
-          </p:cNvPr>
+          <p:cNvPr id="7" name="Slide Number Placeholder 6"/>
           <p:cNvSpPr>
             <a:spLocks noGrp="1"/>
           </p:cNvSpPr>
@@ -1470,7 +1297,7 @@
     </p:spTree>
     <p:extLst>
       <p:ext uri="{BB962C8B-B14F-4D97-AF65-F5344CB8AC3E}">
-        <p14:creationId xmlns:p14="http://schemas.microsoft.com/office/powerpoint/2010/main" val="1919775772"/>
+        <p14:creationId xmlns:p14="http://schemas.microsoft.com/office/powerpoint/2010/main" val="3055177518"/>
       </p:ext>
     </p:extLst>
   </p:cSld>
@@ -1499,13 +1326,7 @@
       </p:grpSpPr>
       <p:sp>
         <p:nvSpPr>
-          <p:cNvPr id="2" name="Title 1">
-            <a:extLst>
-              <a:ext uri="{FF2B5EF4-FFF2-40B4-BE49-F238E27FC236}">
-                <a16:creationId xmlns:a16="http://schemas.microsoft.com/office/drawing/2014/main" id="{89983A4D-FA0E-C0D2-1602-6058461AD1BC}"/>
-              </a:ext>
-            </a:extLst>
-          </p:cNvPr>
+          <p:cNvPr id="2" name="Title 1"/>
           <p:cNvSpPr>
             <a:spLocks noGrp="1"/>
           </p:cNvSpPr>
@@ -1515,8 +1336,8 @@
         </p:nvSpPr>
         <p:spPr>
           <a:xfrm>
-            <a:off x="839789" y="365125"/>
-            <a:ext cx="10515600" cy="1325563"/>
+            <a:off x="535365" y="535519"/>
+            <a:ext cx="6703695" cy="1944159"/>
           </a:xfrm>
         </p:spPr>
         <p:txBody>
@@ -1527,18 +1348,13 @@
               <a:rPr lang="en-US"/>
               <a:t>Click to edit Master title style</a:t>
             </a:r>
-          </a:p>
-        </p:txBody>
-      </p:sp>
-      <p:sp>
-        <p:nvSpPr>
-          <p:cNvPr id="3" name="Text Placeholder 2">
-            <a:extLst>
-              <a:ext uri="{FF2B5EF4-FFF2-40B4-BE49-F238E27FC236}">
-                <a16:creationId xmlns:a16="http://schemas.microsoft.com/office/drawing/2014/main" id="{32AD2737-9746-5DB7-F96E-C9254AE86872}"/>
-              </a:ext>
-            </a:extLst>
-          </p:cNvPr>
+            <a:endParaRPr lang="en-US" dirty="0"/>
+          </a:p>
+        </p:txBody>
+      </p:sp>
+      <p:sp>
+        <p:nvSpPr>
+          <p:cNvPr id="3" name="Text Placeholder 2"/>
           <p:cNvSpPr>
             <a:spLocks noGrp="1"/>
           </p:cNvSpPr>
@@ -1548,8 +1364,8 @@
         </p:nvSpPr>
         <p:spPr>
           <a:xfrm>
-            <a:off x="839789" y="1681163"/>
-            <a:ext cx="5157787" cy="823912"/>
+            <a:off x="535366" y="2465706"/>
+            <a:ext cx="3288089" cy="1208404"/>
           </a:xfrm>
         </p:spPr>
         <p:txBody>
@@ -1557,39 +1373,39 @@
           <a:lstStyle>
             <a:lvl1pPr marL="0" indent="0">
               <a:buNone/>
-              <a:defRPr sz="2400" b="1"/>
+              <a:defRPr sz="2040" b="1"/>
             </a:lvl1pPr>
-            <a:lvl2pPr marL="457206" indent="0">
-              <a:buNone/>
-              <a:defRPr sz="2000" b="1"/>
+            <a:lvl2pPr marL="388620" indent="0">
+              <a:buNone/>
+              <a:defRPr sz="1700" b="1"/>
             </a:lvl2pPr>
-            <a:lvl3pPr marL="914411" indent="0">
-              <a:buNone/>
-              <a:defRPr sz="1801" b="1"/>
+            <a:lvl3pPr marL="777240" indent="0">
+              <a:buNone/>
+              <a:defRPr sz="1530" b="1"/>
             </a:lvl3pPr>
-            <a:lvl4pPr marL="1371617" indent="0">
-              <a:buNone/>
-              <a:defRPr sz="1600" b="1"/>
+            <a:lvl4pPr marL="1165860" indent="0">
+              <a:buNone/>
+              <a:defRPr sz="1360" b="1"/>
             </a:lvl4pPr>
-            <a:lvl5pPr marL="1828823" indent="0">
-              <a:buNone/>
-              <a:defRPr sz="1600" b="1"/>
+            <a:lvl5pPr marL="1554480" indent="0">
+              <a:buNone/>
+              <a:defRPr sz="1360" b="1"/>
             </a:lvl5pPr>
-            <a:lvl6pPr marL="2286029" indent="0">
-              <a:buNone/>
-              <a:defRPr sz="1600" b="1"/>
+            <a:lvl6pPr marL="1943100" indent="0">
+              <a:buNone/>
+              <a:defRPr sz="1360" b="1"/>
             </a:lvl6pPr>
-            <a:lvl7pPr marL="2743234" indent="0">
-              <a:buNone/>
-              <a:defRPr sz="1600" b="1"/>
+            <a:lvl7pPr marL="2331720" indent="0">
+              <a:buNone/>
+              <a:defRPr sz="1360" b="1"/>
             </a:lvl7pPr>
-            <a:lvl8pPr marL="3200440" indent="0">
-              <a:buNone/>
-              <a:defRPr sz="1600" b="1"/>
+            <a:lvl8pPr marL="2720340" indent="0">
+              <a:buNone/>
+              <a:defRPr sz="1360" b="1"/>
             </a:lvl8pPr>
-            <a:lvl9pPr marL="3657646" indent="0">
-              <a:buNone/>
-              <a:defRPr sz="1600" b="1"/>
+            <a:lvl9pPr marL="3108960" indent="0">
+              <a:buNone/>
+              <a:defRPr sz="1360" b="1"/>
             </a:lvl9pPr>
           </a:lstStyle>
           <a:p>
@@ -1603,13 +1419,7 @@
       </p:sp>
       <p:sp>
         <p:nvSpPr>
-          <p:cNvPr id="4" name="Content Placeholder 3">
-            <a:extLst>
-              <a:ext uri="{FF2B5EF4-FFF2-40B4-BE49-F238E27FC236}">
-                <a16:creationId xmlns:a16="http://schemas.microsoft.com/office/drawing/2014/main" id="{B1DA75EE-734F-2A01-7CD0-53456B51EF49}"/>
-              </a:ext>
-            </a:extLst>
-          </p:cNvPr>
+          <p:cNvPr id="4" name="Content Placeholder 3"/>
           <p:cNvSpPr>
             <a:spLocks noGrp="1"/>
           </p:cNvSpPr>
@@ -1619,8 +1429,8 @@
         </p:nvSpPr>
         <p:spPr>
           <a:xfrm>
-            <a:off x="839789" y="2505076"/>
-            <a:ext cx="5157787" cy="3684588"/>
+            <a:off x="535366" y="3674110"/>
+            <a:ext cx="3288089" cy="5404062"/>
           </a:xfrm>
         </p:spPr>
         <p:txBody>
@@ -1660,18 +1470,13 @@
               <a:rPr lang="en-US"/>
               <a:t>Fifth level</a:t>
             </a:r>
-          </a:p>
-        </p:txBody>
-      </p:sp>
-      <p:sp>
-        <p:nvSpPr>
-          <p:cNvPr id="5" name="Text Placeholder 4">
-            <a:extLst>
-              <a:ext uri="{FF2B5EF4-FFF2-40B4-BE49-F238E27FC236}">
-                <a16:creationId xmlns:a16="http://schemas.microsoft.com/office/drawing/2014/main" id="{ECA74715-B566-EBAD-CB0D-19CC4C01688F}"/>
-              </a:ext>
-            </a:extLst>
-          </p:cNvPr>
+            <a:endParaRPr lang="en-US" dirty="0"/>
+          </a:p>
+        </p:txBody>
+      </p:sp>
+      <p:sp>
+        <p:nvSpPr>
+          <p:cNvPr id="5" name="Text Placeholder 4"/>
           <p:cNvSpPr>
             <a:spLocks noGrp="1"/>
           </p:cNvSpPr>
@@ -1681,8 +1486,8 @@
         </p:nvSpPr>
         <p:spPr>
           <a:xfrm>
-            <a:off x="6172202" y="1681163"/>
-            <a:ext cx="5183188" cy="823912"/>
+            <a:off x="3934778" y="2465706"/>
+            <a:ext cx="3304282" cy="1208404"/>
           </a:xfrm>
         </p:spPr>
         <p:txBody>
@@ -1690,39 +1495,39 @@
           <a:lstStyle>
             <a:lvl1pPr marL="0" indent="0">
               <a:buNone/>
-              <a:defRPr sz="2400" b="1"/>
+              <a:defRPr sz="2040" b="1"/>
             </a:lvl1pPr>
-            <a:lvl2pPr marL="457206" indent="0">
-              <a:buNone/>
-              <a:defRPr sz="2000" b="1"/>
+            <a:lvl2pPr marL="388620" indent="0">
+              <a:buNone/>
+              <a:defRPr sz="1700" b="1"/>
             </a:lvl2pPr>
-            <a:lvl3pPr marL="914411" indent="0">
-              <a:buNone/>
-              <a:defRPr sz="1801" b="1"/>
+            <a:lvl3pPr marL="777240" indent="0">
+              <a:buNone/>
+              <a:defRPr sz="1530" b="1"/>
             </a:lvl3pPr>
-            <a:lvl4pPr marL="1371617" indent="0">
-              <a:buNone/>
-              <a:defRPr sz="1600" b="1"/>
+            <a:lvl4pPr marL="1165860" indent="0">
+              <a:buNone/>
+              <a:defRPr sz="1360" b="1"/>
             </a:lvl4pPr>
-            <a:lvl5pPr marL="1828823" indent="0">
-              <a:buNone/>
-              <a:defRPr sz="1600" b="1"/>
+            <a:lvl5pPr marL="1554480" indent="0">
+              <a:buNone/>
+              <a:defRPr sz="1360" b="1"/>
             </a:lvl5pPr>
-            <a:lvl6pPr marL="2286029" indent="0">
-              <a:buNone/>
-              <a:defRPr sz="1600" b="1"/>
+            <a:lvl6pPr marL="1943100" indent="0">
+              <a:buNone/>
+              <a:defRPr sz="1360" b="1"/>
             </a:lvl6pPr>
-            <a:lvl7pPr marL="2743234" indent="0">
-              <a:buNone/>
-              <a:defRPr sz="1600" b="1"/>
+            <a:lvl7pPr marL="2331720" indent="0">
+              <a:buNone/>
+              <a:defRPr sz="1360" b="1"/>
             </a:lvl7pPr>
-            <a:lvl8pPr marL="3200440" indent="0">
-              <a:buNone/>
-              <a:defRPr sz="1600" b="1"/>
+            <a:lvl8pPr marL="2720340" indent="0">
+              <a:buNone/>
+              <a:defRPr sz="1360" b="1"/>
             </a:lvl8pPr>
-            <a:lvl9pPr marL="3657646" indent="0">
-              <a:buNone/>
-              <a:defRPr sz="1600" b="1"/>
+            <a:lvl9pPr marL="3108960" indent="0">
+              <a:buNone/>
+              <a:defRPr sz="1360" b="1"/>
             </a:lvl9pPr>
           </a:lstStyle>
           <a:p>
@@ -1736,13 +1541,7 @@
       </p:sp>
       <p:sp>
         <p:nvSpPr>
-          <p:cNvPr id="6" name="Content Placeholder 5">
-            <a:extLst>
-              <a:ext uri="{FF2B5EF4-FFF2-40B4-BE49-F238E27FC236}">
-                <a16:creationId xmlns:a16="http://schemas.microsoft.com/office/drawing/2014/main" id="{9C66D6C7-478B-A4F2-04C4-F48B47236B69}"/>
-              </a:ext>
-            </a:extLst>
-          </p:cNvPr>
+          <p:cNvPr id="6" name="Content Placeholder 5"/>
           <p:cNvSpPr>
             <a:spLocks noGrp="1"/>
           </p:cNvSpPr>
@@ -1752,8 +1551,8 @@
         </p:nvSpPr>
         <p:spPr>
           <a:xfrm>
-            <a:off x="6172202" y="2505076"/>
-            <a:ext cx="5183188" cy="3684588"/>
+            <a:off x="3934778" y="3674110"/>
+            <a:ext cx="3304282" cy="5404062"/>
           </a:xfrm>
         </p:spPr>
         <p:txBody>
@@ -1793,18 +1592,13 @@
               <a:rPr lang="en-US"/>
               <a:t>Fifth level</a:t>
             </a:r>
-          </a:p>
-        </p:txBody>
-      </p:sp>
-      <p:sp>
-        <p:nvSpPr>
-          <p:cNvPr id="7" name="Date Placeholder 6">
-            <a:extLst>
-              <a:ext uri="{FF2B5EF4-FFF2-40B4-BE49-F238E27FC236}">
-                <a16:creationId xmlns:a16="http://schemas.microsoft.com/office/drawing/2014/main" id="{A711A92E-736C-FED3-5C02-2F67A0B7AE50}"/>
-              </a:ext>
-            </a:extLst>
-          </p:cNvPr>
+            <a:endParaRPr lang="en-US" dirty="0"/>
+          </a:p>
+        </p:txBody>
+      </p:sp>
+      <p:sp>
+        <p:nvSpPr>
+          <p:cNvPr id="7" name="Date Placeholder 6"/>
           <p:cNvSpPr>
             <a:spLocks noGrp="1"/>
           </p:cNvSpPr>
@@ -1819,7 +1613,7 @@
           <a:p>
             <a:fld id="{C99C87EC-6FA1-4B02-B2BA-F8C70409488A}" type="datetimeFigureOut">
               <a:rPr lang="en-US" smtClean="0"/>
-              <a:t>7/28/2026</a:t>
+              <a:t>8/12/2026</a:t>
             </a:fld>
             <a:endParaRPr lang="en-US"/>
           </a:p>
@@ -1827,13 +1621,7 @@
       </p:sp>
       <p:sp>
         <p:nvSpPr>
-          <p:cNvPr id="8" name="Footer Placeholder 7">
-            <a:extLst>
-              <a:ext uri="{FF2B5EF4-FFF2-40B4-BE49-F238E27FC236}">
-                <a16:creationId xmlns:a16="http://schemas.microsoft.com/office/drawing/2014/main" id="{AD5DEB8D-5F14-224D-B0ED-A6F1B41712D2}"/>
-              </a:ext>
-            </a:extLst>
-          </p:cNvPr>
+          <p:cNvPr id="8" name="Footer Placeholder 7"/>
           <p:cNvSpPr>
             <a:spLocks noGrp="1"/>
           </p:cNvSpPr>
@@ -1852,13 +1640,7 @@
       </p:sp>
       <p:sp>
         <p:nvSpPr>
-          <p:cNvPr id="9" name="Slide Number Placeholder 8">
-            <a:extLst>
-              <a:ext uri="{FF2B5EF4-FFF2-40B4-BE49-F238E27FC236}">
-                <a16:creationId xmlns:a16="http://schemas.microsoft.com/office/drawing/2014/main" id="{FA0C7012-B2DF-6B52-A207-7709B6C2F6A5}"/>
-              </a:ext>
-            </a:extLst>
-          </p:cNvPr>
+          <p:cNvPr id="9" name="Slide Number Placeholder 8"/>
           <p:cNvSpPr>
             <a:spLocks noGrp="1"/>
           </p:cNvSpPr>
@@ -1882,7 +1664,7 @@
     </p:spTree>
     <p:extLst>
       <p:ext uri="{BB962C8B-B14F-4D97-AF65-F5344CB8AC3E}">
-        <p14:creationId xmlns:p14="http://schemas.microsoft.com/office/powerpoint/2010/main" val="874698504"/>
+        <p14:creationId xmlns:p14="http://schemas.microsoft.com/office/powerpoint/2010/main" val="1730640627"/>
       </p:ext>
     </p:extLst>
   </p:cSld>
@@ -1911,13 +1693,7 @@
       </p:grpSpPr>
       <p:sp>
         <p:nvSpPr>
-          <p:cNvPr id="2" name="Title 1">
-            <a:extLst>
-              <a:ext uri="{FF2B5EF4-FFF2-40B4-BE49-F238E27FC236}">
-                <a16:creationId xmlns:a16="http://schemas.microsoft.com/office/drawing/2014/main" id="{870D3A87-908D-2047-9A87-E1FA5F1FEBB6}"/>
-              </a:ext>
-            </a:extLst>
-          </p:cNvPr>
+          <p:cNvPr id="2" name="Title 1"/>
           <p:cNvSpPr>
             <a:spLocks noGrp="1"/>
           </p:cNvSpPr>
@@ -1934,18 +1710,13 @@
               <a:rPr lang="en-US"/>
               <a:t>Click to edit Master title style</a:t>
             </a:r>
-          </a:p>
-        </p:txBody>
-      </p:sp>
-      <p:sp>
-        <p:nvSpPr>
-          <p:cNvPr id="3" name="Date Placeholder 2">
-            <a:extLst>
-              <a:ext uri="{FF2B5EF4-FFF2-40B4-BE49-F238E27FC236}">
-                <a16:creationId xmlns:a16="http://schemas.microsoft.com/office/drawing/2014/main" id="{29030CCE-661B-8DFE-721A-71CA8199369B}"/>
-              </a:ext>
-            </a:extLst>
-          </p:cNvPr>
+            <a:endParaRPr lang="en-US" dirty="0"/>
+          </a:p>
+        </p:txBody>
+      </p:sp>
+      <p:sp>
+        <p:nvSpPr>
+          <p:cNvPr id="3" name="Date Placeholder 2"/>
           <p:cNvSpPr>
             <a:spLocks noGrp="1"/>
           </p:cNvSpPr>
@@ -1960,7 +1731,7 @@
           <a:p>
             <a:fld id="{C99C87EC-6FA1-4B02-B2BA-F8C70409488A}" type="datetimeFigureOut">
               <a:rPr lang="en-US" smtClean="0"/>
-              <a:t>7/28/2026</a:t>
+              <a:t>8/12/2026</a:t>
             </a:fld>
             <a:endParaRPr lang="en-US"/>
           </a:p>
@@ -1968,13 +1739,7 @@
       </p:sp>
       <p:sp>
         <p:nvSpPr>
-          <p:cNvPr id="4" name="Footer Placeholder 3">
-            <a:extLst>
-              <a:ext uri="{FF2B5EF4-FFF2-40B4-BE49-F238E27FC236}">
-                <a16:creationId xmlns:a16="http://schemas.microsoft.com/office/drawing/2014/main" id="{C8E0566C-8E9D-CDAC-F645-2214B842E443}"/>
-              </a:ext>
-            </a:extLst>
-          </p:cNvPr>
+          <p:cNvPr id="4" name="Footer Placeholder 3"/>
           <p:cNvSpPr>
             <a:spLocks noGrp="1"/>
           </p:cNvSpPr>
@@ -1993,13 +1758,7 @@
       </p:sp>
       <p:sp>
         <p:nvSpPr>
-          <p:cNvPr id="5" name="Slide Number Placeholder 4">
-            <a:extLst>
-              <a:ext uri="{FF2B5EF4-FFF2-40B4-BE49-F238E27FC236}">
-                <a16:creationId xmlns:a16="http://schemas.microsoft.com/office/drawing/2014/main" id="{ECD71CD2-5276-C643-BD5A-A173A4F17B6C}"/>
-              </a:ext>
-            </a:extLst>
-          </p:cNvPr>
+          <p:cNvPr id="5" name="Slide Number Placeholder 4"/>
           <p:cNvSpPr>
             <a:spLocks noGrp="1"/>
           </p:cNvSpPr>
@@ -2023,7 +1782,7 @@
     </p:spTree>
     <p:extLst>
       <p:ext uri="{BB962C8B-B14F-4D97-AF65-F5344CB8AC3E}">
-        <p14:creationId xmlns:p14="http://schemas.microsoft.com/office/powerpoint/2010/main" val="1404544274"/>
+        <p14:creationId xmlns:p14="http://schemas.microsoft.com/office/powerpoint/2010/main" val="170407274"/>
       </p:ext>
     </p:extLst>
   </p:cSld>
@@ -2052,13 +1811,7 @@
       </p:grpSpPr>
       <p:sp>
         <p:nvSpPr>
-          <p:cNvPr id="2" name="Date Placeholder 1">
-            <a:extLst>
-              <a:ext uri="{FF2B5EF4-FFF2-40B4-BE49-F238E27FC236}">
-                <a16:creationId xmlns:a16="http://schemas.microsoft.com/office/drawing/2014/main" id="{0BE15D1A-DFCA-B756-F63D-ADFD1E83C497}"/>
-              </a:ext>
-            </a:extLst>
-          </p:cNvPr>
+          <p:cNvPr id="2" name="Date Placeholder 1"/>
           <p:cNvSpPr>
             <a:spLocks noGrp="1"/>
           </p:cNvSpPr>
@@ -2073,7 +1826,7 @@
           <a:p>
             <a:fld id="{C99C87EC-6FA1-4B02-B2BA-F8C70409488A}" type="datetimeFigureOut">
               <a:rPr lang="en-US" smtClean="0"/>
-              <a:t>7/28/2026</a:t>
+              <a:t>8/12/2026</a:t>
             </a:fld>
             <a:endParaRPr lang="en-US"/>
           </a:p>
@@ -2081,13 +1834,7 @@
       </p:sp>
       <p:sp>
         <p:nvSpPr>
-          <p:cNvPr id="3" name="Footer Placeholder 2">
-            <a:extLst>
-              <a:ext uri="{FF2B5EF4-FFF2-40B4-BE49-F238E27FC236}">
-                <a16:creationId xmlns:a16="http://schemas.microsoft.com/office/drawing/2014/main" id="{70ADCF62-21BC-380D-7FD7-08445E764B60}"/>
-              </a:ext>
-            </a:extLst>
-          </p:cNvPr>
+          <p:cNvPr id="3" name="Footer Placeholder 2"/>
           <p:cNvSpPr>
             <a:spLocks noGrp="1"/>
           </p:cNvSpPr>
@@ -2106,13 +1853,7 @@
       </p:sp>
       <p:sp>
         <p:nvSpPr>
-          <p:cNvPr id="4" name="Slide Number Placeholder 3">
-            <a:extLst>
-              <a:ext uri="{FF2B5EF4-FFF2-40B4-BE49-F238E27FC236}">
-                <a16:creationId xmlns:a16="http://schemas.microsoft.com/office/drawing/2014/main" id="{D4F1AE60-F711-7AFA-34A4-BBB7A9B25262}"/>
-              </a:ext>
-            </a:extLst>
-          </p:cNvPr>
+          <p:cNvPr id="4" name="Slide Number Placeholder 3"/>
           <p:cNvSpPr>
             <a:spLocks noGrp="1"/>
           </p:cNvSpPr>
@@ -2136,7 +1877,7 @@
     </p:spTree>
     <p:extLst>
       <p:ext uri="{BB962C8B-B14F-4D97-AF65-F5344CB8AC3E}">
-        <p14:creationId xmlns:p14="http://schemas.microsoft.com/office/powerpoint/2010/main" val="3458303653"/>
+        <p14:creationId xmlns:p14="http://schemas.microsoft.com/office/powerpoint/2010/main" val="3612781098"/>
       </p:ext>
     </p:extLst>
   </p:cSld>
@@ -2165,13 +1906,7 @@
       </p:grpSpPr>
       <p:sp>
         <p:nvSpPr>
-          <p:cNvPr id="2" name="Title 1">
-            <a:extLst>
-              <a:ext uri="{FF2B5EF4-FFF2-40B4-BE49-F238E27FC236}">
-                <a16:creationId xmlns:a16="http://schemas.microsoft.com/office/drawing/2014/main" id="{279127C5-C7EC-7AAB-ECC0-56F29433B846}"/>
-              </a:ext>
-            </a:extLst>
-          </p:cNvPr>
+          <p:cNvPr id="2" name="Title 1"/>
           <p:cNvSpPr>
             <a:spLocks noGrp="1"/>
           </p:cNvSpPr>
@@ -2181,15 +1916,15 @@
         </p:nvSpPr>
         <p:spPr>
           <a:xfrm>
-            <a:off x="839790" y="457200"/>
-            <a:ext cx="3932236" cy="1600200"/>
+            <a:off x="535365" y="670560"/>
+            <a:ext cx="2506801" cy="2346960"/>
           </a:xfrm>
         </p:spPr>
         <p:txBody>
           <a:bodyPr anchor="b"/>
           <a:lstStyle>
             <a:lvl1pPr>
-              <a:defRPr sz="3200"/>
+              <a:defRPr sz="2720"/>
             </a:lvl1pPr>
           </a:lstStyle>
           <a:p>
@@ -2197,18 +1932,13 @@
               <a:rPr lang="en-US"/>
               <a:t>Click to edit Master title style</a:t>
             </a:r>
-          </a:p>
-        </p:txBody>
-      </p:sp>
-      <p:sp>
-        <p:nvSpPr>
-          <p:cNvPr id="3" name="Content Placeholder 2">
-            <a:extLst>
-              <a:ext uri="{FF2B5EF4-FFF2-40B4-BE49-F238E27FC236}">
-                <a16:creationId xmlns:a16="http://schemas.microsoft.com/office/drawing/2014/main" id="{9B7275CA-0335-0770-1B6F-755975A25FEC}"/>
-              </a:ext>
-            </a:extLst>
-          </p:cNvPr>
+            <a:endParaRPr lang="en-US" dirty="0"/>
+          </a:p>
+        </p:txBody>
+      </p:sp>
+      <p:sp>
+        <p:nvSpPr>
+          <p:cNvPr id="3" name="Content Placeholder 2"/>
           <p:cNvSpPr>
             <a:spLocks noGrp="1"/>
           </p:cNvSpPr>
@@ -2218,39 +1948,39 @@
         </p:nvSpPr>
         <p:spPr>
           <a:xfrm>
-            <a:off x="5183188" y="987425"/>
-            <a:ext cx="6172201" cy="4873625"/>
+            <a:off x="3304282" y="1448226"/>
+            <a:ext cx="3934778" cy="7147983"/>
           </a:xfrm>
         </p:spPr>
         <p:txBody>
           <a:bodyPr/>
           <a:lstStyle>
             <a:lvl1pPr>
-              <a:defRPr sz="3200"/>
+              <a:defRPr sz="2720"/>
             </a:lvl1pPr>
             <a:lvl2pPr>
-              <a:defRPr sz="2800"/>
+              <a:defRPr sz="2380"/>
             </a:lvl2pPr>
             <a:lvl3pPr>
-              <a:defRPr sz="2400"/>
+              <a:defRPr sz="2040"/>
             </a:lvl3pPr>
             <a:lvl4pPr>
-              <a:defRPr sz="2000"/>
+              <a:defRPr sz="1700"/>
             </a:lvl4pPr>
             <a:lvl5pPr>
-              <a:defRPr sz="2000"/>
+              <a:defRPr sz="1700"/>
             </a:lvl5pPr>
             <a:lvl6pPr>
-              <a:defRPr sz="2000"/>
+              <a:defRPr sz="1700"/>
             </a:lvl6pPr>
             <a:lvl7pPr>
-              <a:defRPr sz="2000"/>
+              <a:defRPr sz="1700"/>
             </a:lvl7pPr>
             <a:lvl8pPr>
-              <a:defRPr sz="2000"/>
+              <a:defRPr sz="1700"/>
             </a:lvl8pPr>
             <a:lvl9pPr>
-              <a:defRPr sz="2000"/>
+              <a:defRPr sz="1700"/>
             </a:lvl9pPr>
           </a:lstStyle>
           <a:p>
@@ -2287,18 +2017,13 @@
               <a:rPr lang="en-US"/>
               <a:t>Fifth level</a:t>
             </a:r>
-          </a:p>
-        </p:txBody>
-      </p:sp>
-      <p:sp>
-        <p:nvSpPr>
-          <p:cNvPr id="4" name="Text Placeholder 3">
-            <a:extLst>
-              <a:ext uri="{FF2B5EF4-FFF2-40B4-BE49-F238E27FC236}">
-                <a16:creationId xmlns:a16="http://schemas.microsoft.com/office/drawing/2014/main" id="{370EBBCC-A8F2-479B-4C9F-62F520A1D1A0}"/>
-              </a:ext>
-            </a:extLst>
-          </p:cNvPr>
+            <a:endParaRPr lang="en-US" dirty="0"/>
+          </a:p>
+        </p:txBody>
+      </p:sp>
+      <p:sp>
+        <p:nvSpPr>
+          <p:cNvPr id="4" name="Text Placeholder 3"/>
           <p:cNvSpPr>
             <a:spLocks noGrp="1"/>
           </p:cNvSpPr>
@@ -2308,8 +2033,8 @@
         </p:nvSpPr>
         <p:spPr>
           <a:xfrm>
-            <a:off x="839790" y="2057400"/>
-            <a:ext cx="3932236" cy="3811588"/>
+            <a:off x="535365" y="3017520"/>
+            <a:ext cx="2506801" cy="5590329"/>
           </a:xfrm>
         </p:spPr>
         <p:txBody>
@@ -2317,39 +2042,39 @@
           <a:lstStyle>
             <a:lvl1pPr marL="0" indent="0">
               <a:buNone/>
-              <a:defRPr sz="1600"/>
+              <a:defRPr sz="1360"/>
             </a:lvl1pPr>
-            <a:lvl2pPr marL="457206" indent="0">
-              <a:buNone/>
-              <a:defRPr sz="1401"/>
+            <a:lvl2pPr marL="388620" indent="0">
+              <a:buNone/>
+              <a:defRPr sz="1190"/>
             </a:lvl2pPr>
-            <a:lvl3pPr marL="914411" indent="0">
-              <a:buNone/>
-              <a:defRPr sz="1200"/>
+            <a:lvl3pPr marL="777240" indent="0">
+              <a:buNone/>
+              <a:defRPr sz="1020"/>
             </a:lvl3pPr>
-            <a:lvl4pPr marL="1371617" indent="0">
-              <a:buNone/>
-              <a:defRPr sz="1001"/>
+            <a:lvl4pPr marL="1165860" indent="0">
+              <a:buNone/>
+              <a:defRPr sz="850"/>
             </a:lvl4pPr>
-            <a:lvl5pPr marL="1828823" indent="0">
-              <a:buNone/>
-              <a:defRPr sz="1001"/>
+            <a:lvl5pPr marL="1554480" indent="0">
+              <a:buNone/>
+              <a:defRPr sz="850"/>
             </a:lvl5pPr>
-            <a:lvl6pPr marL="2286029" indent="0">
-              <a:buNone/>
-              <a:defRPr sz="1001"/>
+            <a:lvl6pPr marL="1943100" indent="0">
+              <a:buNone/>
+              <a:defRPr sz="850"/>
             </a:lvl6pPr>
-            <a:lvl7pPr marL="2743234" indent="0">
-              <a:buNone/>
-              <a:defRPr sz="1001"/>
+            <a:lvl7pPr marL="2331720" indent="0">
+              <a:buNone/>
+              <a:defRPr sz="850"/>
             </a:lvl7pPr>
-            <a:lvl8pPr marL="3200440" indent="0">
-              <a:buNone/>
-              <a:defRPr sz="1001"/>
+            <a:lvl8pPr marL="2720340" indent="0">
+              <a:buNone/>
+              <a:defRPr sz="850"/>
             </a:lvl8pPr>
-            <a:lvl9pPr marL="3657646" indent="0">
-              <a:buNone/>
-              <a:defRPr sz="1001"/>
+            <a:lvl9pPr marL="3108960" indent="0">
+              <a:buNone/>
+              <a:defRPr sz="850"/>
             </a:lvl9pPr>
           </a:lstStyle>
           <a:p>
@@ -2363,13 +2088,7 @@
       </p:sp>
       <p:sp>
         <p:nvSpPr>
-          <p:cNvPr id="5" name="Date Placeholder 4">
-            <a:extLst>
-              <a:ext uri="{FF2B5EF4-FFF2-40B4-BE49-F238E27FC236}">
-                <a16:creationId xmlns:a16="http://schemas.microsoft.com/office/drawing/2014/main" id="{91DE4714-5708-3B23-AF0A-D527C3B58ABD}"/>
-              </a:ext>
-            </a:extLst>
-          </p:cNvPr>
+          <p:cNvPr id="5" name="Date Placeholder 4"/>
           <p:cNvSpPr>
             <a:spLocks noGrp="1"/>
           </p:cNvSpPr>
@@ -2384,7 +2103,7 @@
           <a:p>
             <a:fld id="{C99C87EC-6FA1-4B02-B2BA-F8C70409488A}" type="datetimeFigureOut">
               <a:rPr lang="en-US" smtClean="0"/>
-              <a:t>7/28/2026</a:t>
+              <a:t>8/12/2026</a:t>
             </a:fld>
             <a:endParaRPr lang="en-US"/>
           </a:p>
@@ -2392,13 +2111,7 @@
       </p:sp>
       <p:sp>
         <p:nvSpPr>
-          <p:cNvPr id="6" name="Footer Placeholder 5">
-            <a:extLst>
-              <a:ext uri="{FF2B5EF4-FFF2-40B4-BE49-F238E27FC236}">
-                <a16:creationId xmlns:a16="http://schemas.microsoft.com/office/drawing/2014/main" id="{00FF765A-5C22-5FEE-6D86-4D0FA146A0C6}"/>
-              </a:ext>
-            </a:extLst>
-          </p:cNvPr>
+          <p:cNvPr id="6" name="Footer Placeholder 5"/>
           <p:cNvSpPr>
             <a:spLocks noGrp="1"/>
           </p:cNvSpPr>
@@ -2417,13 +2130,7 @@
       </p:sp>
       <p:sp>
         <p:nvSpPr>
-          <p:cNvPr id="7" name="Slide Number Placeholder 6">
-            <a:extLst>
-              <a:ext uri="{FF2B5EF4-FFF2-40B4-BE49-F238E27FC236}">
-                <a16:creationId xmlns:a16="http://schemas.microsoft.com/office/drawing/2014/main" id="{A4E6EAA6-2943-A369-06F6-B7B47BF6833B}"/>
-              </a:ext>
-            </a:extLst>
-          </p:cNvPr>
+          <p:cNvPr id="7" name="Slide Number Placeholder 6"/>
           <p:cNvSpPr>
             <a:spLocks noGrp="1"/>
           </p:cNvSpPr>
@@ -2447,7 +2154,7 @@
     </p:spTree>
     <p:extLst>
       <p:ext uri="{BB962C8B-B14F-4D97-AF65-F5344CB8AC3E}">
-        <p14:creationId xmlns:p14="http://schemas.microsoft.com/office/powerpoint/2010/main" val="384642505"/>
+        <p14:creationId xmlns:p14="http://schemas.microsoft.com/office/powerpoint/2010/main" val="2820727022"/>
       </p:ext>
     </p:extLst>
   </p:cSld>
@@ -2476,13 +2183,7 @@
       </p:grpSpPr>
       <p:sp>
         <p:nvSpPr>
-          <p:cNvPr id="2" name="Title 1">
-            <a:extLst>
-              <a:ext uri="{FF2B5EF4-FFF2-40B4-BE49-F238E27FC236}">
-                <a16:creationId xmlns:a16="http://schemas.microsoft.com/office/drawing/2014/main" id="{02319E06-FA72-E43C-6B67-139074AB406D}"/>
-              </a:ext>
-            </a:extLst>
-          </p:cNvPr>
+          <p:cNvPr id="2" name="Title 1"/>
           <p:cNvSpPr>
             <a:spLocks noGrp="1"/>
           </p:cNvSpPr>
@@ -2492,15 +2193,15 @@
         </p:nvSpPr>
         <p:spPr>
           <a:xfrm>
-            <a:off x="839790" y="457200"/>
-            <a:ext cx="3932236" cy="1600200"/>
+            <a:off x="535365" y="670560"/>
+            <a:ext cx="2506801" cy="2346960"/>
           </a:xfrm>
         </p:spPr>
         <p:txBody>
           <a:bodyPr anchor="b"/>
           <a:lstStyle>
             <a:lvl1pPr>
-              <a:defRPr sz="3200"/>
+              <a:defRPr sz="2720"/>
             </a:lvl1pPr>
           </a:lstStyle>
           <a:p>
@@ -2508,20 +2209,15 @@
               <a:rPr lang="en-US"/>
               <a:t>Click to edit Master title style</a:t>
             </a:r>
-          </a:p>
-        </p:txBody>
-      </p:sp>
-      <p:sp>
-        <p:nvSpPr>
-          <p:cNvPr id="3" name="Picture Placeholder 2">
-            <a:extLst>
-              <a:ext uri="{FF2B5EF4-FFF2-40B4-BE49-F238E27FC236}">
-                <a16:creationId xmlns:a16="http://schemas.microsoft.com/office/drawing/2014/main" id="{50377CFD-08FE-73D1-E889-A48C689F823D}"/>
-              </a:ext>
-            </a:extLst>
-          </p:cNvPr>
-          <p:cNvSpPr>
-            <a:spLocks noGrp="1"/>
+            <a:endParaRPr lang="en-US" dirty="0"/>
+          </a:p>
+        </p:txBody>
+      </p:sp>
+      <p:sp>
+        <p:nvSpPr>
+          <p:cNvPr id="3" name="Picture Placeholder 2"/>
+          <p:cNvSpPr>
+            <a:spLocks noGrp="1" noChangeAspect="1"/>
           </p:cNvSpPr>
           <p:nvPr>
             <p:ph type="pic" idx="1"/>
@@ -2529,8 +2225,73 @@
         </p:nvSpPr>
         <p:spPr>
           <a:xfrm>
-            <a:off x="5183188" y="987425"/>
-            <a:ext cx="6172201" cy="4873625"/>
+            <a:off x="3304282" y="1448226"/>
+            <a:ext cx="3934778" cy="7147983"/>
+          </a:xfrm>
+        </p:spPr>
+        <p:txBody>
+          <a:bodyPr anchor="t"/>
+          <a:lstStyle>
+            <a:lvl1pPr marL="0" indent="0">
+              <a:buNone/>
+              <a:defRPr sz="2720"/>
+            </a:lvl1pPr>
+            <a:lvl2pPr marL="388620" indent="0">
+              <a:buNone/>
+              <a:defRPr sz="2380"/>
+            </a:lvl2pPr>
+            <a:lvl3pPr marL="777240" indent="0">
+              <a:buNone/>
+              <a:defRPr sz="2040"/>
+            </a:lvl3pPr>
+            <a:lvl4pPr marL="1165860" indent="0">
+              <a:buNone/>
+              <a:defRPr sz="1700"/>
+            </a:lvl4pPr>
+            <a:lvl5pPr marL="1554480" indent="0">
+              <a:buNone/>
+              <a:defRPr sz="1700"/>
+            </a:lvl5pPr>
+            <a:lvl6pPr marL="1943100" indent="0">
+              <a:buNone/>
+              <a:defRPr sz="1700"/>
+            </a:lvl6pPr>
+            <a:lvl7pPr marL="2331720" indent="0">
+              <a:buNone/>
+              <a:defRPr sz="1700"/>
+            </a:lvl7pPr>
+            <a:lvl8pPr marL="2720340" indent="0">
+              <a:buNone/>
+              <a:defRPr sz="1700"/>
+            </a:lvl8pPr>
+            <a:lvl9pPr marL="3108960" indent="0">
+              <a:buNone/>
+              <a:defRPr sz="1700"/>
+            </a:lvl9pPr>
+          </a:lstStyle>
+          <a:p>
+            <a:r>
+              <a:rPr lang="en-US"/>
+              <a:t>Click icon to add picture</a:t>
+            </a:r>
+            <a:endParaRPr lang="en-US" dirty="0"/>
+          </a:p>
+        </p:txBody>
+      </p:sp>
+      <p:sp>
+        <p:nvSpPr>
+          <p:cNvPr id="4" name="Text Placeholder 3"/>
+          <p:cNvSpPr>
+            <a:spLocks noGrp="1"/>
+          </p:cNvSpPr>
+          <p:nvPr>
+            <p:ph type="body" sz="half" idx="2"/>
+          </p:nvPr>
+        </p:nvSpPr>
+        <p:spPr>
+          <a:xfrm>
+            <a:off x="535365" y="3017520"/>
+            <a:ext cx="2506801" cy="5590329"/>
           </a:xfrm>
         </p:spPr>
         <p:txBody>
@@ -2538,109 +2299,42 @@
           <a:lstStyle>
             <a:lvl1pPr marL="0" indent="0">
               <a:buNone/>
-              <a:defRPr sz="3200"/>
+              <a:defRPr sz="1360"/>
             </a:lvl1pPr>
-            <a:lvl2pPr marL="457206" indent="0">
-              <a:buNone/>
-              <a:defRPr sz="2800"/>
+            <a:lvl2pPr marL="388620" indent="0">
+              <a:buNone/>
+              <a:defRPr sz="1190"/>
             </a:lvl2pPr>
-            <a:lvl3pPr marL="914411" indent="0">
-              <a:buNone/>
-              <a:defRPr sz="2400"/>
+            <a:lvl3pPr marL="777240" indent="0">
+              <a:buNone/>
+              <a:defRPr sz="1020"/>
             </a:lvl3pPr>
-            <a:lvl4pPr marL="1371617" indent="0">
-              <a:buNone/>
-              <a:defRPr sz="2000"/>
+            <a:lvl4pPr marL="1165860" indent="0">
+              <a:buNone/>
+              <a:defRPr sz="850"/>
             </a:lvl4pPr>
-            <a:lvl5pPr marL="1828823" indent="0">
-              <a:buNone/>
-              <a:defRPr sz="2000"/>
+            <a:lvl5pPr marL="1554480" indent="0">
+              <a:buNone/>
+              <a:defRPr sz="850"/>
             </a:lvl5pPr>
-            <a:lvl6pPr marL="2286029" indent="0">
-              <a:buNone/>
-              <a:defRPr sz="2000"/>
+            <a:lvl6pPr marL="1943100" indent="0">
+              <a:buNone/>
+              <a:defRPr sz="850"/>
             </a:lvl6pPr>
-            <a:lvl7pPr marL="2743234" indent="0">
-              <a:buNone/>
-              <a:defRPr sz="2000"/>
+            <a:lvl7pPr marL="2331720" indent="0">
+              <a:buNone/>
+              <a:defRPr sz="850"/>
             </a:lvl7pPr>
-            <a:lvl8pPr marL="3200440" indent="0">
-              <a:buNone/>
-              <a:defRPr sz="2000"/>
+            <a:lvl8pPr marL="2720340" indent="0">
+              <a:buNone/>
+              <a:defRPr sz="850"/>
             </a:lvl8pPr>
-            <a:lvl9pPr marL="3657646" indent="0">
-              <a:buNone/>
-              <a:defRPr sz="2000"/>
+            <a:lvl9pPr marL="3108960" indent="0">
+              <a:buNone/>
+              <a:defRPr sz="850"/>
             </a:lvl9pPr>
           </a:lstStyle>
           <a:p>
-            <a:endParaRPr lang="en-US"/>
-          </a:p>
-        </p:txBody>
-      </p:sp>
-      <p:sp>
-        <p:nvSpPr>
-          <p:cNvPr id="4" name="Text Placeholder 3">
-            <a:extLst>
-              <a:ext uri="{FF2B5EF4-FFF2-40B4-BE49-F238E27FC236}">
-                <a16:creationId xmlns:a16="http://schemas.microsoft.com/office/drawing/2014/main" id="{AF5C53C3-4218-25E8-BB7C-DB5164D66DB9}"/>
-              </a:ext>
-            </a:extLst>
-          </p:cNvPr>
-          <p:cNvSpPr>
-            <a:spLocks noGrp="1"/>
-          </p:cNvSpPr>
-          <p:nvPr>
-            <p:ph type="body" sz="half" idx="2"/>
-          </p:nvPr>
-        </p:nvSpPr>
-        <p:spPr>
-          <a:xfrm>
-            <a:off x="839790" y="2057400"/>
-            <a:ext cx="3932236" cy="3811588"/>
-          </a:xfrm>
-        </p:spPr>
-        <p:txBody>
-          <a:bodyPr/>
-          <a:lstStyle>
-            <a:lvl1pPr marL="0" indent="0">
-              <a:buNone/>
-              <a:defRPr sz="1600"/>
-            </a:lvl1pPr>
-            <a:lvl2pPr marL="457206" indent="0">
-              <a:buNone/>
-              <a:defRPr sz="1401"/>
-            </a:lvl2pPr>
-            <a:lvl3pPr marL="914411" indent="0">
-              <a:buNone/>
-              <a:defRPr sz="1200"/>
-            </a:lvl3pPr>
-            <a:lvl4pPr marL="1371617" indent="0">
-              <a:buNone/>
-              <a:defRPr sz="1001"/>
-            </a:lvl4pPr>
-            <a:lvl5pPr marL="1828823" indent="0">
-              <a:buNone/>
-              <a:defRPr sz="1001"/>
-            </a:lvl5pPr>
-            <a:lvl6pPr marL="2286029" indent="0">
-              <a:buNone/>
-              <a:defRPr sz="1001"/>
-            </a:lvl6pPr>
-            <a:lvl7pPr marL="2743234" indent="0">
-              <a:buNone/>
-              <a:defRPr sz="1001"/>
-            </a:lvl7pPr>
-            <a:lvl8pPr marL="3200440" indent="0">
-              <a:buNone/>
-              <a:defRPr sz="1001"/>
-            </a:lvl8pPr>
-            <a:lvl9pPr marL="3657646" indent="0">
-              <a:buNone/>
-              <a:defRPr sz="1001"/>
-            </a:lvl9pPr>
-          </a:lstStyle>
-          <a:p>
             <a:pPr lvl="0"/>
             <a:r>
               <a:rPr lang="en-US"/>
@@ -2651,13 +2345,7 @@
       </p:sp>
       <p:sp>
         <p:nvSpPr>
-          <p:cNvPr id="5" name="Date Placeholder 4">
-            <a:extLst>
-              <a:ext uri="{FF2B5EF4-FFF2-40B4-BE49-F238E27FC236}">
-                <a16:creationId xmlns:a16="http://schemas.microsoft.com/office/drawing/2014/main" id="{AFE75480-BD25-8039-590C-E0848B06C058}"/>
-              </a:ext>
-            </a:extLst>
-          </p:cNvPr>
+          <p:cNvPr id="5" name="Date Placeholder 4"/>
           <p:cNvSpPr>
             <a:spLocks noGrp="1"/>
           </p:cNvSpPr>
@@ -2672,7 +2360,7 @@
           <a:p>
             <a:fld id="{C99C87EC-6FA1-4B02-B2BA-F8C70409488A}" type="datetimeFigureOut">
               <a:rPr lang="en-US" smtClean="0"/>
-              <a:t>7/28/2026</a:t>
+              <a:t>8/12/2026</a:t>
             </a:fld>
             <a:endParaRPr lang="en-US"/>
           </a:p>
@@ -2680,13 +2368,7 @@
       </p:sp>
       <p:sp>
         <p:nvSpPr>
-          <p:cNvPr id="6" name="Footer Placeholder 5">
-            <a:extLst>
-              <a:ext uri="{FF2B5EF4-FFF2-40B4-BE49-F238E27FC236}">
-                <a16:creationId xmlns:a16="http://schemas.microsoft.com/office/drawing/2014/main" id="{C845D6CB-C1E3-4991-B3D8-7698642266D6}"/>
-              </a:ext>
-            </a:extLst>
-          </p:cNvPr>
+          <p:cNvPr id="6" name="Footer Placeholder 5"/>
           <p:cNvSpPr>
             <a:spLocks noGrp="1"/>
           </p:cNvSpPr>
@@ -2705,13 +2387,7 @@
       </p:sp>
       <p:sp>
         <p:nvSpPr>
-          <p:cNvPr id="7" name="Slide Number Placeholder 6">
-            <a:extLst>
-              <a:ext uri="{FF2B5EF4-FFF2-40B4-BE49-F238E27FC236}">
-                <a16:creationId xmlns:a16="http://schemas.microsoft.com/office/drawing/2014/main" id="{519B0E1E-7EDB-C6EF-59F1-60A652934B47}"/>
-              </a:ext>
-            </a:extLst>
-          </p:cNvPr>
+          <p:cNvPr id="7" name="Slide Number Placeholder 6"/>
           <p:cNvSpPr>
             <a:spLocks noGrp="1"/>
           </p:cNvSpPr>
@@ -2735,7 +2411,7 @@
     </p:spTree>
     <p:extLst>
       <p:ext uri="{BB962C8B-B14F-4D97-AF65-F5344CB8AC3E}">
-        <p14:creationId xmlns:p14="http://schemas.microsoft.com/office/powerpoint/2010/main" val="630603710"/>
+        <p14:creationId xmlns:p14="http://schemas.microsoft.com/office/powerpoint/2010/main" val="1070232465"/>
       </p:ext>
     </p:extLst>
   </p:cSld>
@@ -2769,13 +2445,7 @@
       </p:grpSpPr>
       <p:sp>
         <p:nvSpPr>
-          <p:cNvPr id="2" name="Title Placeholder 1">
-            <a:extLst>
-              <a:ext uri="{FF2B5EF4-FFF2-40B4-BE49-F238E27FC236}">
-                <a16:creationId xmlns:a16="http://schemas.microsoft.com/office/drawing/2014/main" id="{152C44D3-A6DD-99CD-0BA2-FD26581B6001}"/>
-              </a:ext>
-            </a:extLst>
-          </p:cNvPr>
+          <p:cNvPr id="2" name="Title Placeholder 1"/>
           <p:cNvSpPr>
             <a:spLocks noGrp="1"/>
           </p:cNvSpPr>
@@ -2785,8 +2455,8 @@
         </p:nvSpPr>
         <p:spPr>
           <a:xfrm>
-            <a:off x="838202" y="365125"/>
-            <a:ext cx="10515600" cy="1325563"/>
+            <a:off x="534353" y="535519"/>
+            <a:ext cx="6703695" cy="1944159"/>
           </a:xfrm>
           <a:prstGeom prst="rect">
             <a:avLst/>
@@ -2802,18 +2472,13 @@
               <a:rPr lang="en-US"/>
               <a:t>Click to edit Master title style</a:t>
             </a:r>
-          </a:p>
-        </p:txBody>
-      </p:sp>
-      <p:sp>
-        <p:nvSpPr>
-          <p:cNvPr id="3" name="Text Placeholder 2">
-            <a:extLst>
-              <a:ext uri="{FF2B5EF4-FFF2-40B4-BE49-F238E27FC236}">
-                <a16:creationId xmlns:a16="http://schemas.microsoft.com/office/drawing/2014/main" id="{36103636-364C-9B78-5C07-9656954BE59B}"/>
-              </a:ext>
-            </a:extLst>
-          </p:cNvPr>
+            <a:endParaRPr lang="en-US" dirty="0"/>
+          </a:p>
+        </p:txBody>
+      </p:sp>
+      <p:sp>
+        <p:nvSpPr>
+          <p:cNvPr id="3" name="Text Placeholder 2"/>
           <p:cNvSpPr>
             <a:spLocks noGrp="1"/>
           </p:cNvSpPr>
@@ -2823,8 +2488,8 @@
         </p:nvSpPr>
         <p:spPr>
           <a:xfrm>
-            <a:off x="838202" y="1825625"/>
-            <a:ext cx="10515600" cy="4351338"/>
+            <a:off x="534353" y="2677584"/>
+            <a:ext cx="6703695" cy="6381962"/>
           </a:xfrm>
           <a:prstGeom prst="rect">
             <a:avLst/>
@@ -2869,18 +2534,13 @@
               <a:rPr lang="en-US"/>
               <a:t>Fifth level</a:t>
             </a:r>
-          </a:p>
-        </p:txBody>
-      </p:sp>
-      <p:sp>
-        <p:nvSpPr>
-          <p:cNvPr id="4" name="Date Placeholder 3">
-            <a:extLst>
-              <a:ext uri="{FF2B5EF4-FFF2-40B4-BE49-F238E27FC236}">
-                <a16:creationId xmlns:a16="http://schemas.microsoft.com/office/drawing/2014/main" id="{576DF393-5543-6130-98FF-D8E4AE0A0A64}"/>
-              </a:ext>
-            </a:extLst>
-          </p:cNvPr>
+            <a:endParaRPr lang="en-US" dirty="0"/>
+          </a:p>
+        </p:txBody>
+      </p:sp>
+      <p:sp>
+        <p:nvSpPr>
+          <p:cNvPr id="4" name="Date Placeholder 3"/>
           <p:cNvSpPr>
             <a:spLocks noGrp="1"/>
           </p:cNvSpPr>
@@ -2890,8 +2550,8 @@
         </p:nvSpPr>
         <p:spPr>
           <a:xfrm>
-            <a:off x="838201" y="6356351"/>
-            <a:ext cx="2743200" cy="365125"/>
+            <a:off x="534353" y="9322649"/>
+            <a:ext cx="1748790" cy="535517"/>
           </a:xfrm>
           <a:prstGeom prst="rect">
             <a:avLst/>
@@ -2901,7 +2561,7 @@
           <a:bodyPr vert="horz" lIns="91440" tIns="45720" rIns="91440" bIns="45720" rtlCol="0" anchor="ctr"/>
           <a:lstStyle>
             <a:lvl1pPr algn="l">
-              <a:defRPr sz="1200">
+              <a:defRPr sz="1020">
                 <a:solidFill>
                   <a:schemeClr val="tx1">
                     <a:tint val="82000"/>
@@ -2913,7 +2573,7 @@
           <a:p>
             <a:fld id="{C99C87EC-6FA1-4B02-B2BA-F8C70409488A}" type="datetimeFigureOut">
               <a:rPr lang="en-US" smtClean="0"/>
-              <a:t>7/28/2026</a:t>
+              <a:t>8/12/2026</a:t>
             </a:fld>
             <a:endParaRPr lang="en-US"/>
           </a:p>
@@ -2921,13 +2581,7 @@
       </p:sp>
       <p:sp>
         <p:nvSpPr>
-          <p:cNvPr id="5" name="Footer Placeholder 4">
-            <a:extLst>
-              <a:ext uri="{FF2B5EF4-FFF2-40B4-BE49-F238E27FC236}">
-                <a16:creationId xmlns:a16="http://schemas.microsoft.com/office/drawing/2014/main" id="{3EE1184F-430B-355D-23E0-D1D7FBA1F266}"/>
-              </a:ext>
-            </a:extLst>
-          </p:cNvPr>
+          <p:cNvPr id="5" name="Footer Placeholder 4"/>
           <p:cNvSpPr>
             <a:spLocks noGrp="1"/>
           </p:cNvSpPr>
@@ -2937,8 +2591,8 @@
         </p:nvSpPr>
         <p:spPr>
           <a:xfrm>
-            <a:off x="4038602" y="6356351"/>
-            <a:ext cx="4114800" cy="365125"/>
+            <a:off x="2574608" y="9322649"/>
+            <a:ext cx="2623185" cy="535517"/>
           </a:xfrm>
           <a:prstGeom prst="rect">
             <a:avLst/>
@@ -2948,7 +2602,7 @@
           <a:bodyPr vert="horz" lIns="91440" tIns="45720" rIns="91440" bIns="45720" rtlCol="0" anchor="ctr"/>
           <a:lstStyle>
             <a:lvl1pPr algn="ctr">
-              <a:defRPr sz="1200">
+              <a:defRPr sz="1020">
                 <a:solidFill>
                   <a:schemeClr val="tx1">
                     <a:tint val="82000"/>
@@ -2964,13 +2618,7 @@
       </p:sp>
       <p:sp>
         <p:nvSpPr>
-          <p:cNvPr id="6" name="Slide Number Placeholder 5">
-            <a:extLst>
-              <a:ext uri="{FF2B5EF4-FFF2-40B4-BE49-F238E27FC236}">
-                <a16:creationId xmlns:a16="http://schemas.microsoft.com/office/drawing/2014/main" id="{9E28B2AB-52B1-8740-97BC-AABC3DCFAD5F}"/>
-              </a:ext>
-            </a:extLst>
-          </p:cNvPr>
+          <p:cNvPr id="6" name="Slide Number Placeholder 5"/>
           <p:cNvSpPr>
             <a:spLocks noGrp="1"/>
           </p:cNvSpPr>
@@ -2980,8 +2628,8 @@
         </p:nvSpPr>
         <p:spPr>
           <a:xfrm>
-            <a:off x="8610601" y="6356351"/>
-            <a:ext cx="2743200" cy="365125"/>
+            <a:off x="5489258" y="9322649"/>
+            <a:ext cx="1748790" cy="535517"/>
           </a:xfrm>
           <a:prstGeom prst="rect">
             <a:avLst/>
@@ -2991,7 +2639,7 @@
           <a:bodyPr vert="horz" lIns="91440" tIns="45720" rIns="91440" bIns="45720" rtlCol="0" anchor="ctr"/>
           <a:lstStyle>
             <a:lvl1pPr algn="r">
-              <a:defRPr sz="1200">
+              <a:defRPr sz="1020">
                 <a:solidFill>
                   <a:schemeClr val="tx1">
                     <a:tint val="82000"/>
@@ -3012,27 +2660,27 @@
     </p:spTree>
     <p:extLst>
       <p:ext uri="{BB962C8B-B14F-4D97-AF65-F5344CB8AC3E}">
-        <p14:creationId xmlns:p14="http://schemas.microsoft.com/office/powerpoint/2010/main" val="1670295737"/>
+        <p14:creationId xmlns:p14="http://schemas.microsoft.com/office/powerpoint/2010/main" val="1040532025"/>
       </p:ext>
     </p:extLst>
   </p:cSld>
   <p:clrMap bg1="lt1" tx1="dk1" bg2="lt2" tx2="dk2" accent1="accent1" accent2="accent2" accent3="accent3" accent4="accent4" accent5="accent5" accent6="accent6" hlink="hlink" folHlink="folHlink"/>
   <p:sldLayoutIdLst>
-    <p:sldLayoutId id="2147483649" r:id="rId1"/>
-    <p:sldLayoutId id="2147483650" r:id="rId2"/>
-    <p:sldLayoutId id="2147483651" r:id="rId3"/>
-    <p:sldLayoutId id="2147483652" r:id="rId4"/>
-    <p:sldLayoutId id="2147483653" r:id="rId5"/>
-    <p:sldLayoutId id="2147483654" r:id="rId6"/>
-    <p:sldLayoutId id="2147483655" r:id="rId7"/>
-    <p:sldLayoutId id="2147483656" r:id="rId8"/>
-    <p:sldLayoutId id="2147483657" r:id="rId9"/>
-    <p:sldLayoutId id="2147483658" r:id="rId10"/>
-    <p:sldLayoutId id="2147483659" r:id="rId11"/>
+    <p:sldLayoutId id="2147483661" r:id="rId1"/>
+    <p:sldLayoutId id="2147483662" r:id="rId2"/>
+    <p:sldLayoutId id="2147483663" r:id="rId3"/>
+    <p:sldLayoutId id="2147483664" r:id="rId4"/>
+    <p:sldLayoutId id="2147483665" r:id="rId5"/>
+    <p:sldLayoutId id="2147483666" r:id="rId6"/>
+    <p:sldLayoutId id="2147483667" r:id="rId7"/>
+    <p:sldLayoutId id="2147483668" r:id="rId8"/>
+    <p:sldLayoutId id="2147483669" r:id="rId9"/>
+    <p:sldLayoutId id="2147483670" r:id="rId10"/>
+    <p:sldLayoutId id="2147483671" r:id="rId11"/>
   </p:sldLayoutIdLst>
   <p:txStyles>
     <p:titleStyle>
-      <a:lvl1pPr algn="l" defTabSz="914411" rtl="0" eaLnBrk="1" latinLnBrk="0" hangingPunct="1">
+      <a:lvl1pPr algn="l" defTabSz="777240" rtl="0" eaLnBrk="1" latinLnBrk="0" hangingPunct="1">
         <a:lnSpc>
           <a:spcPct val="90000"/>
         </a:lnSpc>
@@ -3040,7 +2688,7 @@
           <a:spcPct val="0"/>
         </a:spcBef>
         <a:buNone/>
-        <a:defRPr sz="4400" kern="1200">
+        <a:defRPr sz="3740" kern="1200">
           <a:solidFill>
             <a:schemeClr val="tx1"/>
           </a:solidFill>
@@ -3051,16 +2699,16 @@
       </a:lvl1pPr>
     </p:titleStyle>
     <p:bodyStyle>
-      <a:lvl1pPr marL="228604" indent="-228604" algn="l" defTabSz="914411" rtl="0" eaLnBrk="1" latinLnBrk="0" hangingPunct="1">
+      <a:lvl1pPr marL="194310" indent="-194310" algn="l" defTabSz="777240" rtl="0" eaLnBrk="1" latinLnBrk="0" hangingPunct="1">
         <a:lnSpc>
           <a:spcPct val="90000"/>
         </a:lnSpc>
         <a:spcBef>
-          <a:spcPts val="1001"/>
+          <a:spcPts val="850"/>
         </a:spcBef>
         <a:buFont typeface="Arial" panose="020B0604020202020204" pitchFamily="34" charset="0"/>
         <a:buChar char="•"/>
-        <a:defRPr sz="2800" kern="1200">
+        <a:defRPr sz="2380" kern="1200">
           <a:solidFill>
             <a:schemeClr val="tx1"/>
           </a:solidFill>
@@ -3069,16 +2717,16 @@
           <a:cs typeface="+mn-cs"/>
         </a:defRPr>
       </a:lvl1pPr>
-      <a:lvl2pPr marL="685809" indent="-228604" algn="l" defTabSz="914411" rtl="0" eaLnBrk="1" latinLnBrk="0" hangingPunct="1">
+      <a:lvl2pPr marL="582930" indent="-194310" algn="l" defTabSz="777240" rtl="0" eaLnBrk="1" latinLnBrk="0" hangingPunct="1">
         <a:lnSpc>
           <a:spcPct val="90000"/>
         </a:lnSpc>
         <a:spcBef>
-          <a:spcPts val="500"/>
+          <a:spcPts val="425"/>
         </a:spcBef>
         <a:buFont typeface="Arial" panose="020B0604020202020204" pitchFamily="34" charset="0"/>
         <a:buChar char="•"/>
-        <a:defRPr sz="2400" kern="1200">
+        <a:defRPr sz="2040" kern="1200">
           <a:solidFill>
             <a:schemeClr val="tx1"/>
           </a:solidFill>
@@ -3087,16 +2735,16 @@
           <a:cs typeface="+mn-cs"/>
         </a:defRPr>
       </a:lvl2pPr>
-      <a:lvl3pPr marL="1143015" indent="-228604" algn="l" defTabSz="914411" rtl="0" eaLnBrk="1" latinLnBrk="0" hangingPunct="1">
+      <a:lvl3pPr marL="971550" indent="-194310" algn="l" defTabSz="777240" rtl="0" eaLnBrk="1" latinLnBrk="0" hangingPunct="1">
         <a:lnSpc>
           <a:spcPct val="90000"/>
         </a:lnSpc>
         <a:spcBef>
-          <a:spcPts val="500"/>
+          <a:spcPts val="425"/>
         </a:spcBef>
         <a:buFont typeface="Arial" panose="020B0604020202020204" pitchFamily="34" charset="0"/>
         <a:buChar char="•"/>
-        <a:defRPr sz="2000" kern="1200">
+        <a:defRPr sz="1700" kern="1200">
           <a:solidFill>
             <a:schemeClr val="tx1"/>
           </a:solidFill>
@@ -3105,16 +2753,16 @@
           <a:cs typeface="+mn-cs"/>
         </a:defRPr>
       </a:lvl3pPr>
-      <a:lvl4pPr marL="1600221" indent="-228604" algn="l" defTabSz="914411" rtl="0" eaLnBrk="1" latinLnBrk="0" hangingPunct="1">
+      <a:lvl4pPr marL="1360170" indent="-194310" algn="l" defTabSz="777240" rtl="0" eaLnBrk="1" latinLnBrk="0" hangingPunct="1">
         <a:lnSpc>
           <a:spcPct val="90000"/>
         </a:lnSpc>
         <a:spcBef>
-          <a:spcPts val="500"/>
+          <a:spcPts val="425"/>
         </a:spcBef>
         <a:buFont typeface="Arial" panose="020B0604020202020204" pitchFamily="34" charset="0"/>
         <a:buChar char="•"/>
-        <a:defRPr sz="1801" kern="1200">
+        <a:defRPr sz="1530" kern="1200">
           <a:solidFill>
             <a:schemeClr val="tx1"/>
           </a:solidFill>
@@ -3123,16 +2771,16 @@
           <a:cs typeface="+mn-cs"/>
         </a:defRPr>
       </a:lvl4pPr>
-      <a:lvl5pPr marL="2057427" indent="-228604" algn="l" defTabSz="914411" rtl="0" eaLnBrk="1" latinLnBrk="0" hangingPunct="1">
+      <a:lvl5pPr marL="1748790" indent="-194310" algn="l" defTabSz="777240" rtl="0" eaLnBrk="1" latinLnBrk="0" hangingPunct="1">
         <a:lnSpc>
           <a:spcPct val="90000"/>
         </a:lnSpc>
         <a:spcBef>
-          <a:spcPts val="500"/>
+          <a:spcPts val="425"/>
         </a:spcBef>
         <a:buFont typeface="Arial" panose="020B0604020202020204" pitchFamily="34" charset="0"/>
         <a:buChar char="•"/>
-        <a:defRPr sz="1801" kern="1200">
+        <a:defRPr sz="1530" kern="1200">
           <a:solidFill>
             <a:schemeClr val="tx1"/>
           </a:solidFill>
@@ -3141,16 +2789,16 @@
           <a:cs typeface="+mn-cs"/>
         </a:defRPr>
       </a:lvl5pPr>
-      <a:lvl6pPr marL="2514632" indent="-228604" algn="l" defTabSz="914411" rtl="0" eaLnBrk="1" latinLnBrk="0" hangingPunct="1">
+      <a:lvl6pPr marL="2137410" indent="-194310" algn="l" defTabSz="777240" rtl="0" eaLnBrk="1" latinLnBrk="0" hangingPunct="1">
         <a:lnSpc>
           <a:spcPct val="90000"/>
         </a:lnSpc>
         <a:spcBef>
-          <a:spcPts val="500"/>
+          <a:spcPts val="425"/>
         </a:spcBef>
         <a:buFont typeface="Arial" panose="020B0604020202020204" pitchFamily="34" charset="0"/>
         <a:buChar char="•"/>
-        <a:defRPr sz="1801" kern="1200">
+        <a:defRPr sz="1530" kern="1200">
           <a:solidFill>
             <a:schemeClr val="tx1"/>
           </a:solidFill>
@@ -3159,16 +2807,16 @@
           <a:cs typeface="+mn-cs"/>
         </a:defRPr>
       </a:lvl6pPr>
-      <a:lvl7pPr marL="2971838" indent="-228604" algn="l" defTabSz="914411" rtl="0" eaLnBrk="1" latinLnBrk="0" hangingPunct="1">
+      <a:lvl7pPr marL="2526030" indent="-194310" algn="l" defTabSz="777240" rtl="0" eaLnBrk="1" latinLnBrk="0" hangingPunct="1">
         <a:lnSpc>
           <a:spcPct val="90000"/>
         </a:lnSpc>
         <a:spcBef>
-          <a:spcPts val="500"/>
+          <a:spcPts val="425"/>
         </a:spcBef>
         <a:buFont typeface="Arial" panose="020B0604020202020204" pitchFamily="34" charset="0"/>
         <a:buChar char="•"/>
-        <a:defRPr sz="1801" kern="1200">
+        <a:defRPr sz="1530" kern="1200">
           <a:solidFill>
             <a:schemeClr val="tx1"/>
           </a:solidFill>
@@ -3177,16 +2825,16 @@
           <a:cs typeface="+mn-cs"/>
         </a:defRPr>
       </a:lvl7pPr>
-      <a:lvl8pPr marL="3429044" indent="-228604" algn="l" defTabSz="914411" rtl="0" eaLnBrk="1" latinLnBrk="0" hangingPunct="1">
+      <a:lvl8pPr marL="2914650" indent="-194310" algn="l" defTabSz="777240" rtl="0" eaLnBrk="1" latinLnBrk="0" hangingPunct="1">
         <a:lnSpc>
           <a:spcPct val="90000"/>
         </a:lnSpc>
         <a:spcBef>
-          <a:spcPts val="500"/>
+          <a:spcPts val="425"/>
         </a:spcBef>
         <a:buFont typeface="Arial" panose="020B0604020202020204" pitchFamily="34" charset="0"/>
         <a:buChar char="•"/>
-        <a:defRPr sz="1801" kern="1200">
+        <a:defRPr sz="1530" kern="1200">
           <a:solidFill>
             <a:schemeClr val="tx1"/>
           </a:solidFill>
@@ -3195,16 +2843,16 @@
           <a:cs typeface="+mn-cs"/>
         </a:defRPr>
       </a:lvl8pPr>
-      <a:lvl9pPr marL="3886249" indent="-228604" algn="l" defTabSz="914411" rtl="0" eaLnBrk="1" latinLnBrk="0" hangingPunct="1">
+      <a:lvl9pPr marL="3303270" indent="-194310" algn="l" defTabSz="777240" rtl="0" eaLnBrk="1" latinLnBrk="0" hangingPunct="1">
         <a:lnSpc>
           <a:spcPct val="90000"/>
         </a:lnSpc>
         <a:spcBef>
-          <a:spcPts val="500"/>
+          <a:spcPts val="425"/>
         </a:spcBef>
         <a:buFont typeface="Arial" panose="020B0604020202020204" pitchFamily="34" charset="0"/>
         <a:buChar char="•"/>
-        <a:defRPr sz="1801" kern="1200">
+        <a:defRPr sz="1530" kern="1200">
           <a:solidFill>
             <a:schemeClr val="tx1"/>
           </a:solidFill>
@@ -3218,8 +2866,8 @@
       <a:defPPr>
         <a:defRPr lang="en-US"/>
       </a:defPPr>
-      <a:lvl1pPr marL="0" algn="l" defTabSz="914411" rtl="0" eaLnBrk="1" latinLnBrk="0" hangingPunct="1">
-        <a:defRPr sz="1801" kern="1200">
+      <a:lvl1pPr marL="0" algn="l" defTabSz="777240" rtl="0" eaLnBrk="1" latinLnBrk="0" hangingPunct="1">
+        <a:defRPr sz="1530" kern="1200">
           <a:solidFill>
             <a:schemeClr val="tx1"/>
           </a:solidFill>
@@ -3228,8 +2876,8 @@
           <a:cs typeface="+mn-cs"/>
         </a:defRPr>
       </a:lvl1pPr>
-      <a:lvl2pPr marL="457206" algn="l" defTabSz="914411" rtl="0" eaLnBrk="1" latinLnBrk="0" hangingPunct="1">
-        <a:defRPr sz="1801" kern="1200">
+      <a:lvl2pPr marL="388620" algn="l" defTabSz="777240" rtl="0" eaLnBrk="1" latinLnBrk="0" hangingPunct="1">
+        <a:defRPr sz="1530" kern="1200">
           <a:solidFill>
             <a:schemeClr val="tx1"/>
           </a:solidFill>
@@ -3238,8 +2886,8 @@
           <a:cs typeface="+mn-cs"/>
         </a:defRPr>
       </a:lvl2pPr>
-      <a:lvl3pPr marL="914411" algn="l" defTabSz="914411" rtl="0" eaLnBrk="1" latinLnBrk="0" hangingPunct="1">
-        <a:defRPr sz="1801" kern="1200">
+      <a:lvl3pPr marL="777240" algn="l" defTabSz="777240" rtl="0" eaLnBrk="1" latinLnBrk="0" hangingPunct="1">
+        <a:defRPr sz="1530" kern="1200">
           <a:solidFill>
             <a:schemeClr val="tx1"/>
           </a:solidFill>
@@ -3248,8 +2896,8 @@
           <a:cs typeface="+mn-cs"/>
         </a:defRPr>
       </a:lvl3pPr>
-      <a:lvl4pPr marL="1371617" algn="l" defTabSz="914411" rtl="0" eaLnBrk="1" latinLnBrk="0" hangingPunct="1">
-        <a:defRPr sz="1801" kern="1200">
+      <a:lvl4pPr marL="1165860" algn="l" defTabSz="777240" rtl="0" eaLnBrk="1" latinLnBrk="0" hangingPunct="1">
+        <a:defRPr sz="1530" kern="1200">
           <a:solidFill>
             <a:schemeClr val="tx1"/>
           </a:solidFill>
@@ -3258,8 +2906,8 @@
           <a:cs typeface="+mn-cs"/>
         </a:defRPr>
       </a:lvl4pPr>
-      <a:lvl5pPr marL="1828823" algn="l" defTabSz="914411" rtl="0" eaLnBrk="1" latinLnBrk="0" hangingPunct="1">
-        <a:defRPr sz="1801" kern="1200">
+      <a:lvl5pPr marL="1554480" algn="l" defTabSz="777240" rtl="0" eaLnBrk="1" latinLnBrk="0" hangingPunct="1">
+        <a:defRPr sz="1530" kern="1200">
           <a:solidFill>
             <a:schemeClr val="tx1"/>
           </a:solidFill>
@@ -3268,8 +2916,8 @@
           <a:cs typeface="+mn-cs"/>
         </a:defRPr>
       </a:lvl5pPr>
-      <a:lvl6pPr marL="2286029" algn="l" defTabSz="914411" rtl="0" eaLnBrk="1" latinLnBrk="0" hangingPunct="1">
-        <a:defRPr sz="1801" kern="1200">
+      <a:lvl6pPr marL="1943100" algn="l" defTabSz="777240" rtl="0" eaLnBrk="1" latinLnBrk="0" hangingPunct="1">
+        <a:defRPr sz="1530" kern="1200">
           <a:solidFill>
             <a:schemeClr val="tx1"/>
           </a:solidFill>
@@ -3278,8 +2926,8 @@
           <a:cs typeface="+mn-cs"/>
         </a:defRPr>
       </a:lvl6pPr>
-      <a:lvl7pPr marL="2743234" algn="l" defTabSz="914411" rtl="0" eaLnBrk="1" latinLnBrk="0" hangingPunct="1">
-        <a:defRPr sz="1801" kern="1200">
+      <a:lvl7pPr marL="2331720" algn="l" defTabSz="777240" rtl="0" eaLnBrk="1" latinLnBrk="0" hangingPunct="1">
+        <a:defRPr sz="1530" kern="1200">
           <a:solidFill>
             <a:schemeClr val="tx1"/>
           </a:solidFill>
@@ -3288,8 +2936,8 @@
           <a:cs typeface="+mn-cs"/>
         </a:defRPr>
       </a:lvl7pPr>
-      <a:lvl8pPr marL="3200440" algn="l" defTabSz="914411" rtl="0" eaLnBrk="1" latinLnBrk="0" hangingPunct="1">
-        <a:defRPr sz="1801" kern="1200">
+      <a:lvl8pPr marL="2720340" algn="l" defTabSz="777240" rtl="0" eaLnBrk="1" latinLnBrk="0" hangingPunct="1">
+        <a:defRPr sz="1530" kern="1200">
           <a:solidFill>
             <a:schemeClr val="tx1"/>
           </a:solidFill>
@@ -3298,8 +2946,8 @@
           <a:cs typeface="+mn-cs"/>
         </a:defRPr>
       </a:lvl8pPr>
-      <a:lvl9pPr marL="3657646" algn="l" defTabSz="914411" rtl="0" eaLnBrk="1" latinLnBrk="0" hangingPunct="1">
-        <a:defRPr sz="1801" kern="1200">
+      <a:lvl9pPr marL="3108960" algn="l" defTabSz="777240" rtl="0" eaLnBrk="1" latinLnBrk="0" hangingPunct="1">
+        <a:defRPr sz="1530" kern="1200">
           <a:solidFill>
             <a:schemeClr val="tx1"/>
           </a:solidFill>
@@ -3346,8 +2994,8 @@
         </p:nvGrpSpPr>
         <p:grpSpPr>
           <a:xfrm>
-            <a:off x="3266586" y="45720"/>
-            <a:ext cx="5116312" cy="6766560"/>
+            <a:off x="1149556" y="1098856"/>
+            <a:ext cx="5943600" cy="7860687"/>
             <a:chOff x="3198339" y="-416858"/>
             <a:chExt cx="6400800" cy="8465364"/>
           </a:xfrm>
@@ -3430,9 +3078,9 @@
             <p:grpSpPr>
               <a:xfrm>
                 <a:off x="3198339" y="-416858"/>
-                <a:ext cx="6400800" cy="4421907"/>
+                <a:ext cx="6400800" cy="4430477"/>
                 <a:chOff x="3198340" y="-416858"/>
-                <a:chExt cx="5943601" cy="4106057"/>
+                <a:chExt cx="5943601" cy="4114015"/>
               </a:xfrm>
             </p:grpSpPr>
             <p:pic>
@@ -3491,7 +3139,7 @@
               <p:spPr>
                 <a:xfrm>
                   <a:off x="3198340" y="-416858"/>
-                  <a:ext cx="137160" cy="260199"/>
+                  <a:ext cx="137160" cy="268157"/>
                 </a:xfrm>
                 <a:prstGeom prst="rect">
                   <a:avLst/>
@@ -3506,14 +3154,14 @@
                 </a:ln>
               </p:spPr>
               <p:txBody>
-                <a:bodyPr wrap="square" lIns="91440" rIns="91440" rtlCol="0">
+                <a:bodyPr wrap="square" lIns="134112" rIns="134112" rtlCol="0">
                   <a:spAutoFit/>
                 </a:bodyPr>
                 <a:lstStyle/>
                 <a:p>
                   <a:pPr algn="ctr"/>
                   <a:r>
-                    <a:rPr lang="en-US" sz="1091" b="1" dirty="0">
+                    <a:rPr lang="en-US" sz="1600" b="1" dirty="0">
                       <a:latin typeface="Arial" panose="020B0604020202020204" pitchFamily="34" charset="0"/>
                       <a:cs typeface="Arial" panose="020B0604020202020204" pitchFamily="34" charset="0"/>
                     </a:rPr>
@@ -3537,7 +3185,7 @@
               <p:spPr>
                 <a:xfrm>
                   <a:off x="3198341" y="3429000"/>
-                  <a:ext cx="137160" cy="260199"/>
+                  <a:ext cx="137160" cy="268157"/>
                 </a:xfrm>
                 <a:prstGeom prst="rect">
                   <a:avLst/>
@@ -3557,7 +3205,7 @@
                 <a:p>
                   <a:pPr algn="ctr"/>
                   <a:r>
-                    <a:rPr lang="en-US" sz="1091" b="1" dirty="0">
+                    <a:rPr lang="en-US" sz="1600" b="1" dirty="0">
                       <a:latin typeface="Arial" panose="020B0604020202020204" pitchFamily="34" charset="0"/>
                       <a:cs typeface="Arial" panose="020B0604020202020204" pitchFamily="34" charset="0"/>
                     </a:rPr>
@@ -3582,8 +3230,8 @@
           </p:nvSpPr>
           <p:spPr>
             <a:xfrm>
-              <a:off x="3917950" y="3939088"/>
-              <a:ext cx="1247775" cy="246221"/>
+              <a:off x="3917950" y="3906815"/>
+              <a:ext cx="1552252" cy="271338"/>
             </a:xfrm>
             <a:prstGeom prst="rect">
               <a:avLst/>
@@ -3597,7 +3245,7 @@
             <a:lstStyle/>
             <a:p>
               <a:r>
-                <a:rPr lang="en-US" sz="1000" dirty="0">
+                <a:rPr lang="en-US" sz="1467" dirty="0">
                   <a:solidFill>
                     <a:srgbClr val="C400FF"/>
                   </a:solidFill>
@@ -3623,8 +3271,8 @@
           </p:nvSpPr>
           <p:spPr>
             <a:xfrm>
-              <a:off x="6851650" y="5801660"/>
-              <a:ext cx="1247775" cy="246221"/>
+              <a:off x="6738098" y="5763560"/>
+              <a:ext cx="1247775" cy="271338"/>
             </a:xfrm>
             <a:prstGeom prst="rect">
               <a:avLst/>
@@ -3638,7 +3286,7 @@
             <a:lstStyle/>
             <a:p>
               <a:r>
-                <a:rPr lang="en-US" sz="1000" dirty="0">
+                <a:rPr lang="en-US" sz="1467" dirty="0">
                   <a:solidFill>
                     <a:srgbClr val="28A100"/>
                   </a:solidFill>
@@ -3690,13 +3338,15 @@
               </a:ext>
             </a:extLst>
           </p:cNvPr>
-          <p:cNvGrpSpPr/>
+          <p:cNvGrpSpPr>
+            <a:grpSpLocks noChangeAspect="1"/>
+          </p:cNvGrpSpPr>
           <p:nvPr/>
         </p:nvGrpSpPr>
         <p:grpSpPr>
           <a:xfrm>
-            <a:off x="2102380" y="1709726"/>
-            <a:ext cx="7767205" cy="3071813"/>
+            <a:off x="914400" y="2285927"/>
+            <a:ext cx="5943600" cy="2350605"/>
             <a:chOff x="238685" y="2507596"/>
             <a:chExt cx="11391900" cy="4505325"/>
           </a:xfrm>
@@ -3786,7 +3436,7 @@
           <p:spPr>
             <a:xfrm>
               <a:off x="238685" y="2507596"/>
-              <a:ext cx="229863" cy="381908"/>
+              <a:ext cx="229863" cy="338875"/>
             </a:xfrm>
             <a:prstGeom prst="rect">
               <a:avLst/>
@@ -3806,7 +3456,7 @@
             <a:p>
               <a:pPr algn="ctr"/>
               <a:r>
-                <a:rPr lang="en-US" sz="1092" b="1" dirty="0">
+                <a:rPr lang="en-US" sz="1602" b="1" dirty="0">
                   <a:latin typeface="Arial" panose="020B0604020202020204" pitchFamily="34" charset="0"/>
                   <a:cs typeface="Arial" panose="020B0604020202020204" pitchFamily="34" charset="0"/>
                 </a:rPr>
@@ -3830,7 +3480,7 @@
           <p:spPr>
             <a:xfrm>
               <a:off x="5934636" y="2507596"/>
-              <a:ext cx="229863" cy="381908"/>
+              <a:ext cx="229863" cy="338875"/>
             </a:xfrm>
             <a:prstGeom prst="rect">
               <a:avLst/>
@@ -3850,7 +3500,7 @@
             <a:p>
               <a:pPr algn="ctr"/>
               <a:r>
-                <a:rPr lang="en-US" sz="1092" b="1" dirty="0">
+                <a:rPr lang="en-US" sz="1602" b="1" dirty="0">
                   <a:latin typeface="Arial" panose="020B0604020202020204" pitchFamily="34" charset="0"/>
                   <a:cs typeface="Arial" panose="020B0604020202020204" pitchFamily="34" charset="0"/>
                 </a:rPr>
@@ -3910,10 +3560,10 @@
         </p:nvGrpSpPr>
         <p:grpSpPr>
           <a:xfrm>
-            <a:off x="2112415" y="1154009"/>
-            <a:ext cx="3154100" cy="3186233"/>
+            <a:off x="1573193" y="1747966"/>
+            <a:ext cx="4626013" cy="4630125"/>
             <a:chOff x="253407" y="1692543"/>
-            <a:chExt cx="4626009" cy="4673140"/>
+            <a:chExt cx="4626009" cy="4630124"/>
           </a:xfrm>
         </p:grpSpPr>
         <p:pic>
@@ -3966,7 +3616,7 @@
           <p:spPr>
             <a:xfrm>
               <a:off x="1350259" y="5657902"/>
-              <a:ext cx="636586" cy="185076"/>
+              <a:ext cx="636586" cy="185115"/>
             </a:xfrm>
             <a:prstGeom prst="rect">
               <a:avLst/>
@@ -3979,11 +3629,11 @@
             </a:bodyPr>
             <a:lstStyle/>
             <a:p>
-              <a:pPr defTabSz="311735">
+              <a:pPr defTabSz="457222">
                 <a:defRPr/>
               </a:pPr>
               <a:r>
-                <a:rPr lang="en-US" sz="820" dirty="0">
+                <a:rPr lang="en-US" sz="1203" dirty="0">
                   <a:solidFill>
                     <a:prstClr val="black"/>
                   </a:solidFill>
@@ -4010,7 +3660,7 @@
           <p:spPr>
             <a:xfrm>
               <a:off x="2487244" y="5657902"/>
-              <a:ext cx="571034" cy="185076"/>
+              <a:ext cx="571034" cy="185115"/>
             </a:xfrm>
             <a:prstGeom prst="rect">
               <a:avLst/>
@@ -4023,11 +3673,11 @@
             </a:bodyPr>
             <a:lstStyle/>
             <a:p>
-              <a:pPr defTabSz="311735">
+              <a:pPr defTabSz="457222">
                 <a:defRPr/>
               </a:pPr>
               <a:r>
-                <a:rPr lang="en-US" sz="820" dirty="0">
+                <a:rPr lang="en-US" sz="1203" dirty="0">
                   <a:solidFill>
                     <a:prstClr val="black"/>
                   </a:solidFill>
@@ -4054,7 +3704,7 @@
           <p:spPr>
             <a:xfrm>
               <a:off x="3564188" y="5657902"/>
-              <a:ext cx="700962" cy="185076"/>
+              <a:ext cx="700962" cy="185115"/>
             </a:xfrm>
             <a:prstGeom prst="rect">
               <a:avLst/>
@@ -4067,11 +3717,11 @@
             </a:bodyPr>
             <a:lstStyle/>
             <a:p>
-              <a:pPr defTabSz="311735">
+              <a:pPr defTabSz="457222">
                 <a:defRPr/>
               </a:pPr>
               <a:r>
-                <a:rPr lang="en-US" sz="820" dirty="0">
+                <a:rPr lang="en-US" sz="1203" dirty="0">
                   <a:solidFill>
                     <a:prstClr val="black"/>
                   </a:solidFill>
@@ -4098,7 +3748,7 @@
           <p:spPr>
             <a:xfrm>
               <a:off x="4402544" y="5657902"/>
-              <a:ext cx="410669" cy="185076"/>
+              <a:ext cx="410669" cy="185115"/>
             </a:xfrm>
             <a:prstGeom prst="rect">
               <a:avLst/>
@@ -4111,11 +3761,11 @@
             </a:bodyPr>
             <a:lstStyle/>
             <a:p>
-              <a:pPr algn="ctr" defTabSz="311735">
+              <a:pPr algn="ctr" defTabSz="457222">
                 <a:defRPr/>
               </a:pPr>
               <a:r>
-                <a:rPr lang="en-US" sz="820" dirty="0">
+                <a:rPr lang="en-US" sz="1203" dirty="0">
                   <a:solidFill>
                     <a:prstClr val="black"/>
                   </a:solidFill>
@@ -4274,7 +3924,7 @@
           <p:spPr>
             <a:xfrm>
               <a:off x="1308457" y="5880526"/>
-              <a:ext cx="405504" cy="154136"/>
+              <a:ext cx="405504" cy="154209"/>
             </a:xfrm>
             <a:prstGeom prst="rect">
               <a:avLst/>
@@ -4287,11 +3937,11 @@
             </a:bodyPr>
             <a:lstStyle/>
             <a:p>
-              <a:pPr algn="ctr" defTabSz="311735">
+              <a:pPr algn="ctr" defTabSz="457222">
                 <a:defRPr/>
               </a:pPr>
               <a:r>
-                <a:rPr lang="en-US" sz="683" dirty="0">
+                <a:rPr lang="en-US" sz="1002" dirty="0">
                   <a:solidFill>
                     <a:prstClr val="black"/>
                   </a:solidFill>
@@ -4318,7 +3968,7 @@
           <p:spPr>
             <a:xfrm>
               <a:off x="2433005" y="5880526"/>
-              <a:ext cx="443289" cy="154136"/>
+              <a:ext cx="443289" cy="154209"/>
             </a:xfrm>
             <a:prstGeom prst="rect">
               <a:avLst/>
@@ -4331,11 +3981,11 @@
             </a:bodyPr>
             <a:lstStyle/>
             <a:p>
-              <a:pPr algn="ctr" defTabSz="311735">
+              <a:pPr algn="ctr" defTabSz="457222">
                 <a:defRPr/>
               </a:pPr>
               <a:r>
-                <a:rPr lang="en-US" sz="683" dirty="0">
+                <a:rPr lang="en-US" sz="1002" dirty="0">
                   <a:solidFill>
                     <a:prstClr val="black"/>
                   </a:solidFill>
@@ -4362,7 +4012,7 @@
           <p:spPr>
             <a:xfrm>
               <a:off x="3416170" y="5880526"/>
-              <a:ext cx="700957" cy="154136"/>
+              <a:ext cx="700957" cy="154209"/>
             </a:xfrm>
             <a:prstGeom prst="rect">
               <a:avLst/>
@@ -4375,11 +4025,11 @@
             </a:bodyPr>
             <a:lstStyle/>
             <a:p>
-              <a:pPr algn="ctr" defTabSz="311735">
+              <a:pPr algn="ctr" defTabSz="457222">
                 <a:defRPr/>
               </a:pPr>
               <a:r>
-                <a:rPr lang="en-US" sz="683" dirty="0">
+                <a:rPr lang="en-US" sz="1002" dirty="0">
                   <a:solidFill>
                     <a:prstClr val="black"/>
                   </a:solidFill>
@@ -4405,8 +4055,8 @@
           </p:nvSpPr>
           <p:spPr>
             <a:xfrm>
-              <a:off x="4366495" y="5880977"/>
-              <a:ext cx="505582" cy="154136"/>
+              <a:off x="4366495" y="5880978"/>
+              <a:ext cx="505582" cy="154209"/>
             </a:xfrm>
             <a:prstGeom prst="rect">
               <a:avLst/>
@@ -4419,11 +4069,11 @@
             </a:bodyPr>
             <a:lstStyle/>
             <a:p>
-              <a:pPr algn="ctr" defTabSz="311735">
+              <a:pPr algn="ctr" defTabSz="457222">
                 <a:defRPr/>
               </a:pPr>
               <a:r>
-                <a:rPr lang="en-US" sz="683" dirty="0">
+                <a:rPr lang="en-US" sz="1002" dirty="0">
                   <a:solidFill>
                     <a:prstClr val="black"/>
                   </a:solidFill>
@@ -4450,7 +4100,7 @@
           <p:spPr>
             <a:xfrm>
               <a:off x="261041" y="6076125"/>
-              <a:ext cx="1679383" cy="289558"/>
+              <a:ext cx="1679383" cy="246542"/>
             </a:xfrm>
             <a:prstGeom prst="rect">
               <a:avLst/>
@@ -4464,7 +4114,7 @@
             <a:lstStyle/>
             <a:p>
               <a:r>
-                <a:rPr lang="en-US" sz="683" dirty="0">
+                <a:rPr lang="en-US" sz="1002" dirty="0">
                   <a:latin typeface="Arial" panose="020B0604020202020204" pitchFamily="34" charset="0"/>
                   <a:cs typeface="Arial" panose="020B0604020202020204" pitchFamily="34" charset="0"/>
                 </a:rPr>
@@ -4488,7 +4138,7 @@
           <p:spPr>
             <a:xfrm>
               <a:off x="1314819" y="6131037"/>
-              <a:ext cx="405504" cy="154136"/>
+              <a:ext cx="405504" cy="154209"/>
             </a:xfrm>
             <a:prstGeom prst="rect">
               <a:avLst/>
@@ -4501,11 +4151,11 @@
             </a:bodyPr>
             <a:lstStyle/>
             <a:p>
-              <a:pPr algn="ctr" defTabSz="311735">
+              <a:pPr algn="ctr" defTabSz="457222">
                 <a:defRPr/>
               </a:pPr>
               <a:r>
-                <a:rPr lang="en-US" sz="683" dirty="0">
+                <a:rPr lang="en-US" sz="1002" dirty="0">
                   <a:solidFill>
                     <a:prstClr val="black"/>
                   </a:solidFill>
@@ -4531,8 +4181,8 @@
           </p:nvSpPr>
           <p:spPr>
             <a:xfrm>
-              <a:off x="2323838" y="6135401"/>
-              <a:ext cx="739820" cy="154136"/>
+              <a:off x="2323838" y="6135400"/>
+              <a:ext cx="739820" cy="154209"/>
             </a:xfrm>
             <a:prstGeom prst="rect">
               <a:avLst/>
@@ -4545,11 +4195,11 @@
             </a:bodyPr>
             <a:lstStyle/>
             <a:p>
-              <a:pPr algn="ctr" defTabSz="311735">
+              <a:pPr algn="ctr" defTabSz="457222">
                 <a:defRPr/>
               </a:pPr>
               <a:r>
-                <a:rPr lang="en-US" sz="683" dirty="0">
+                <a:rPr lang="en-US" sz="1002" dirty="0">
                   <a:solidFill>
                     <a:prstClr val="black"/>
                   </a:solidFill>
@@ -4576,7 +4226,7 @@
           <p:spPr>
             <a:xfrm>
               <a:off x="3581837" y="6125660"/>
-              <a:ext cx="410437" cy="154136"/>
+              <a:ext cx="410437" cy="154209"/>
             </a:xfrm>
             <a:prstGeom prst="rect">
               <a:avLst/>
@@ -4589,11 +4239,11 @@
             </a:bodyPr>
             <a:lstStyle/>
             <a:p>
-              <a:pPr algn="ctr" defTabSz="311735">
+              <a:pPr algn="ctr" defTabSz="457222">
                 <a:defRPr/>
               </a:pPr>
               <a:r>
-                <a:rPr lang="en-US" sz="683" dirty="0">
+                <a:rPr lang="en-US" sz="1002" dirty="0">
                   <a:solidFill>
                     <a:prstClr val="black"/>
                   </a:solidFill>
@@ -4620,7 +4270,7 @@
           <p:spPr>
             <a:xfrm>
               <a:off x="4366495" y="6125660"/>
-              <a:ext cx="505582" cy="154136"/>
+              <a:ext cx="505582" cy="154209"/>
             </a:xfrm>
             <a:prstGeom prst="rect">
               <a:avLst/>
@@ -4633,11 +4283,11 @@
             </a:bodyPr>
             <a:lstStyle/>
             <a:p>
-              <a:pPr algn="ctr" defTabSz="311735">
+              <a:pPr algn="ctr" defTabSz="457222">
                 <a:defRPr/>
               </a:pPr>
               <a:r>
-                <a:rPr lang="en-US" sz="683" dirty="0">
+                <a:rPr lang="en-US" sz="1002" dirty="0">
                   <a:solidFill>
                     <a:prstClr val="black"/>
                   </a:solidFill>
@@ -4664,7 +4314,7 @@
           <p:spPr>
             <a:xfrm>
               <a:off x="253407" y="5762561"/>
-              <a:ext cx="1048177" cy="443694"/>
+              <a:ext cx="1048177" cy="400751"/>
             </a:xfrm>
             <a:prstGeom prst="rect">
               <a:avLst/>
@@ -4678,7 +4328,7 @@
             <a:lstStyle/>
             <a:p>
               <a:r>
-                <a:rPr lang="en-US" sz="683" dirty="0">
+                <a:rPr lang="en-US" sz="1002" dirty="0">
                   <a:latin typeface="Arial" panose="020B0604020202020204" pitchFamily="34" charset="0"/>
                   <a:cs typeface="Arial" panose="020B0604020202020204" pitchFamily="34" charset="0"/>
                 </a:rPr>
@@ -4702,7 +4352,7 @@
           <p:spPr>
             <a:xfrm>
               <a:off x="1027186" y="3282553"/>
-              <a:ext cx="307799" cy="412378"/>
+              <a:ext cx="307799" cy="369332"/>
             </a:xfrm>
             <a:prstGeom prst="rect">
               <a:avLst/>
@@ -4716,7 +4366,7 @@
             <a:lstStyle/>
             <a:p>
               <a:r>
-                <a:rPr lang="en-US" sz="1227" dirty="0"/>
+                <a:rPr lang="en-US" dirty="0"/>
                 <a:t>*</a:t>
               </a:r>
             </a:p>
@@ -4737,7 +4387,7 @@
           <p:spPr>
             <a:xfrm>
               <a:off x="2105955" y="4715071"/>
-              <a:ext cx="460201" cy="412378"/>
+              <a:ext cx="460201" cy="369332"/>
             </a:xfrm>
             <a:prstGeom prst="rect">
               <a:avLst/>
@@ -4751,7 +4401,7 @@
             <a:lstStyle/>
             <a:p>
               <a:r>
-                <a:rPr lang="en-US" sz="1227" dirty="0"/>
+                <a:rPr lang="en-US" dirty="0"/>
                 <a:t>*</a:t>
               </a:r>
             </a:p>
@@ -4772,7 +4422,7 @@
           <p:spPr>
             <a:xfrm>
               <a:off x="3191142" y="1692543"/>
-              <a:ext cx="512539" cy="412378"/>
+              <a:ext cx="512539" cy="369332"/>
             </a:xfrm>
             <a:prstGeom prst="rect">
               <a:avLst/>
@@ -4789,7 +4439,7 @@
             <a:lstStyle/>
             <a:p>
               <a:r>
-                <a:rPr lang="en-US" sz="1227" dirty="0">
+                <a:rPr lang="en-US" dirty="0">
                   <a:solidFill>
                     <a:schemeClr val="bg1"/>
                   </a:solidFill>
@@ -4814,7 +4464,7 @@
           <p:spPr>
             <a:xfrm>
               <a:off x="3549907" y="1692543"/>
-              <a:ext cx="512539" cy="412378"/>
+              <a:ext cx="512539" cy="369332"/>
             </a:xfrm>
             <a:prstGeom prst="rect">
               <a:avLst/>
@@ -4831,7 +4481,7 @@
             <a:lstStyle/>
             <a:p>
               <a:r>
-                <a:rPr lang="en-US" sz="1227" dirty="0">
+                <a:rPr lang="en-US" dirty="0">
                   <a:solidFill>
                     <a:schemeClr val="bg1"/>
                   </a:solidFill>
@@ -4889,7 +4539,7 @@
             <a:lstStyle/>
             <a:p>
               <a:pPr algn="ctr"/>
-              <a:endParaRPr lang="en-US" sz="1227"/>
+              <a:endParaRPr lang="en-US"/>
             </a:p>
           </p:txBody>
         </p:sp>
@@ -4907,8 +4557,8 @@
           </p:nvSpPr>
           <p:spPr>
             <a:xfrm>
-              <a:off x="1062527" y="2715554"/>
-              <a:ext cx="118556" cy="412378"/>
+              <a:off x="1062527" y="2715555"/>
+              <a:ext cx="118556" cy="369332"/>
             </a:xfrm>
             <a:prstGeom prst="rect">
               <a:avLst/>
@@ -4922,7 +4572,7 @@
             <a:lstStyle/>
             <a:p>
               <a:r>
-                <a:rPr lang="en-US" sz="1227" dirty="0"/>
+                <a:rPr lang="en-US" dirty="0"/>
                 <a:t>*</a:t>
               </a:r>
             </a:p>
@@ -4959,432 +4609,367 @@
           <a:chExt cx="0" cy="0"/>
         </a:xfrm>
       </p:grpSpPr>
-      <p:grpSp>
-        <p:nvGrpSpPr>
-          <p:cNvPr id="41" name="Group 40">
+      <p:pic>
+        <p:nvPicPr>
+          <p:cNvPr id="40" name="Picture 39">
             <a:extLst>
               <a:ext uri="{FF2B5EF4-FFF2-40B4-BE49-F238E27FC236}">
-                <a16:creationId xmlns:a16="http://schemas.microsoft.com/office/drawing/2014/main" id="{417E32AE-700A-E403-2B95-A4228B82EAF2}"/>
+                <a16:creationId xmlns:a16="http://schemas.microsoft.com/office/drawing/2014/main" id="{3C719814-3C6A-EE64-28D8-C999A4E5C70F}"/>
               </a:ext>
             </a:extLst>
           </p:cNvPr>
-          <p:cNvGrpSpPr>
-            <a:grpSpLocks noChangeAspect="1"/>
-          </p:cNvGrpSpPr>
+          <p:cNvPicPr>
+            <a:picLocks noChangeAspect="1"/>
+          </p:cNvPicPr>
           <p:nvPr/>
-        </p:nvGrpSpPr>
-        <p:grpSpPr>
+        </p:nvPicPr>
+        <p:blipFill>
+          <a:blip r:embed="rId2">
+            <a:extLst>
+              <a:ext uri="{28A0092B-C50C-407E-A947-70E740481C1C}">
+                <a14:useLocalDpi xmlns:a14="http://schemas.microsoft.com/office/drawing/2010/main" val="0"/>
+              </a:ext>
+            </a:extLst>
+          </a:blip>
+          <a:srcRect b="9428"/>
+          <a:stretch>
+            <a:fillRect/>
+          </a:stretch>
+        </p:blipFill>
+        <p:spPr>
           <a:xfrm>
-            <a:off x="3541254" y="98943"/>
-            <a:ext cx="4210436" cy="6309360"/>
-            <a:chOff x="3159105" y="-597096"/>
-            <a:chExt cx="5486402" cy="8221389"/>
+            <a:off x="914400" y="6871933"/>
+            <a:ext cx="5943600" cy="2070476"/>
           </a:xfrm>
-        </p:grpSpPr>
-        <p:pic>
-          <p:nvPicPr>
-            <p:cNvPr id="40" name="Picture 39">
-              <a:extLst>
-                <a:ext uri="{FF2B5EF4-FFF2-40B4-BE49-F238E27FC236}">
-                  <a16:creationId xmlns:a16="http://schemas.microsoft.com/office/drawing/2014/main" id="{3C719814-3C6A-EE64-28D8-C999A4E5C70F}"/>
-                </a:ext>
-              </a:extLst>
-            </p:cNvPr>
-            <p:cNvPicPr>
-              <a:picLocks noChangeAspect="1"/>
-            </p:cNvPicPr>
-            <p:nvPr/>
-          </p:nvPicPr>
-          <p:blipFill>
-            <a:blip r:embed="rId2">
-              <a:extLst>
-                <a:ext uri="{28A0092B-C50C-407E-A947-70E740481C1C}">
-                  <a14:useLocalDpi xmlns:a14="http://schemas.microsoft.com/office/drawing/2010/main" val="0"/>
-                </a:ext>
-              </a:extLst>
-            </a:blip>
-            <a:srcRect b="9428"/>
-            <a:stretch>
-              <a:fillRect/>
-            </a:stretch>
-          </p:blipFill>
-          <p:spPr>
-            <a:xfrm>
-              <a:off x="3159107" y="5713087"/>
-              <a:ext cx="5486400" cy="1911206"/>
-            </a:xfrm>
-            <a:prstGeom prst="rect">
-              <a:avLst/>
-            </a:prstGeom>
-            <a:ln>
-              <a:solidFill>
-                <a:schemeClr val="tx1"/>
-              </a:solidFill>
-            </a:ln>
-          </p:spPr>
-        </p:pic>
-        <p:grpSp>
-          <p:nvGrpSpPr>
-            <p:cNvPr id="24" name="Group 23">
-              <a:extLst>
-                <a:ext uri="{FF2B5EF4-FFF2-40B4-BE49-F238E27FC236}">
-                  <a16:creationId xmlns:a16="http://schemas.microsoft.com/office/drawing/2014/main" id="{63CC0A53-1520-9AFC-F553-9268C07F0E2F}"/>
-                </a:ext>
-              </a:extLst>
-            </p:cNvPr>
-            <p:cNvGrpSpPr/>
-            <p:nvPr/>
-          </p:nvGrpSpPr>
-          <p:grpSpPr>
-            <a:xfrm>
-              <a:off x="3159105" y="-597096"/>
-              <a:ext cx="5486402" cy="8021173"/>
-              <a:chOff x="3159105" y="-597096"/>
-              <a:chExt cx="5486402" cy="8021173"/>
-            </a:xfrm>
-          </p:grpSpPr>
-          <p:grpSp>
-            <p:nvGrpSpPr>
-              <p:cNvPr id="18" name="Group 17">
-                <a:extLst>
-                  <a:ext uri="{FF2B5EF4-FFF2-40B4-BE49-F238E27FC236}">
-                    <a16:creationId xmlns:a16="http://schemas.microsoft.com/office/drawing/2014/main" id="{F812F60B-40DF-7B8D-8EDB-3D242F95CDAE}"/>
-                  </a:ext>
-                </a:extLst>
-              </p:cNvPr>
-              <p:cNvGrpSpPr/>
-              <p:nvPr/>
-            </p:nvGrpSpPr>
-            <p:grpSpPr>
-              <a:xfrm>
-                <a:off x="3159105" y="-597096"/>
-                <a:ext cx="5486402" cy="6666102"/>
-                <a:chOff x="3159105" y="-597096"/>
-                <a:chExt cx="5486402" cy="6666102"/>
-              </a:xfrm>
-            </p:grpSpPr>
-            <p:pic>
-              <p:nvPicPr>
-                <p:cNvPr id="5" name="Picture 4">
-                  <a:extLst>
-                    <a:ext uri="{FF2B5EF4-FFF2-40B4-BE49-F238E27FC236}">
-                      <a16:creationId xmlns:a16="http://schemas.microsoft.com/office/drawing/2014/main" id="{4A5E02E6-2F94-948A-D365-515D285A5274}"/>
-                    </a:ext>
-                  </a:extLst>
-                </p:cNvPr>
-                <p:cNvPicPr>
-                  <a:picLocks noChangeAspect="1"/>
-                </p:cNvPicPr>
-                <p:nvPr/>
-              </p:nvPicPr>
-              <p:blipFill>
-                <a:blip r:embed="rId3">
-                  <a:extLst>
-                    <a:ext uri="{28A0092B-C50C-407E-A947-70E740481C1C}">
-                      <a14:useLocalDpi xmlns:a14="http://schemas.microsoft.com/office/drawing/2010/main" val="0"/>
-                    </a:ext>
-                  </a:extLst>
-                </a:blip>
-                <a:stretch>
-                  <a:fillRect/>
-                </a:stretch>
-              </p:blipFill>
-              <p:spPr>
-                <a:xfrm>
-                  <a:off x="3159107" y="-597096"/>
-                  <a:ext cx="5486400" cy="6405711"/>
-                </a:xfrm>
-                <a:prstGeom prst="rect">
-                  <a:avLst/>
-                </a:prstGeom>
-                <a:ln>
-                  <a:solidFill>
-                    <a:schemeClr val="tx1"/>
-                  </a:solidFill>
-                </a:ln>
-              </p:spPr>
-            </p:pic>
-            <p:sp>
-              <p:nvSpPr>
-                <p:cNvPr id="16" name="TextBox 15">
-                  <a:extLst>
-                    <a:ext uri="{FF2B5EF4-FFF2-40B4-BE49-F238E27FC236}">
-                      <a16:creationId xmlns:a16="http://schemas.microsoft.com/office/drawing/2014/main" id="{78762A43-995E-60B4-835D-4D2F126C6D06}"/>
-                    </a:ext>
-                  </a:extLst>
-                </p:cNvPr>
-                <p:cNvSpPr txBox="1"/>
-                <p:nvPr/>
-              </p:nvSpPr>
-              <p:spPr>
-                <a:xfrm>
-                  <a:off x="3159105" y="-597096"/>
-                  <a:ext cx="156725" cy="260392"/>
-                </a:xfrm>
-                <a:prstGeom prst="rect">
-                  <a:avLst/>
-                </a:prstGeom>
-                <a:noFill/>
-                <a:ln w="12700">
-                  <a:solidFill>
-                    <a:schemeClr val="tx1"/>
-                  </a:solidFill>
-                </a:ln>
-              </p:spPr>
-              <p:txBody>
-                <a:bodyPr wrap="square" rtlCol="0">
-                  <a:spAutoFit/>
-                </a:bodyPr>
-                <a:lstStyle/>
-                <a:p>
-                  <a:pPr algn="ctr"/>
-                  <a:r>
-                    <a:rPr lang="en-US" sz="1092" b="1" dirty="0">
-                      <a:latin typeface="Arial" panose="020B0604020202020204" pitchFamily="34" charset="0"/>
-                      <a:cs typeface="Arial" panose="020B0604020202020204" pitchFamily="34" charset="0"/>
-                    </a:rPr>
-                    <a:t>A</a:t>
-                  </a:r>
-                </a:p>
-              </p:txBody>
-            </p:sp>
-            <p:sp>
-              <p:nvSpPr>
-                <p:cNvPr id="17" name="TextBox 16">
-                  <a:extLst>
-                    <a:ext uri="{FF2B5EF4-FFF2-40B4-BE49-F238E27FC236}">
-                      <a16:creationId xmlns:a16="http://schemas.microsoft.com/office/drawing/2014/main" id="{3784CAE7-B813-0BBD-E932-3A64CD2008DF}"/>
-                    </a:ext>
-                  </a:extLst>
-                </p:cNvPr>
-                <p:cNvSpPr txBox="1"/>
-                <p:nvPr/>
-              </p:nvSpPr>
-              <p:spPr>
-                <a:xfrm>
-                  <a:off x="3159109" y="5808614"/>
-                  <a:ext cx="156725" cy="260392"/>
-                </a:xfrm>
-                <a:prstGeom prst="rect">
-                  <a:avLst/>
-                </a:prstGeom>
-                <a:noFill/>
-                <a:ln w="12700">
-                  <a:solidFill>
-                    <a:schemeClr val="tx1"/>
-                  </a:solidFill>
-                </a:ln>
-              </p:spPr>
-              <p:txBody>
-                <a:bodyPr wrap="square" rtlCol="0">
-                  <a:spAutoFit/>
-                </a:bodyPr>
-                <a:lstStyle/>
-                <a:p>
-                  <a:pPr algn="ctr"/>
-                  <a:r>
-                    <a:rPr lang="en-US" sz="1092" b="1" dirty="0">
-                      <a:latin typeface="Arial" panose="020B0604020202020204" pitchFamily="34" charset="0"/>
-                      <a:cs typeface="Arial" panose="020B0604020202020204" pitchFamily="34" charset="0"/>
-                    </a:rPr>
-                    <a:t>B</a:t>
-                  </a:r>
-                </a:p>
-              </p:txBody>
-            </p:sp>
-          </p:grpSp>
-          <p:sp>
-            <p:nvSpPr>
-              <p:cNvPr id="19" name="TextBox 18">
-                <a:extLst>
-                  <a:ext uri="{FF2B5EF4-FFF2-40B4-BE49-F238E27FC236}">
-                    <a16:creationId xmlns:a16="http://schemas.microsoft.com/office/drawing/2014/main" id="{0E592B03-AD14-BB32-06DA-33307CDFA942}"/>
-                  </a:ext>
-                </a:extLst>
-              </p:cNvPr>
-              <p:cNvSpPr txBox="1"/>
-              <p:nvPr/>
-            </p:nvSpPr>
-            <p:spPr>
-              <a:xfrm>
-                <a:off x="3932484" y="6663198"/>
-                <a:ext cx="209419" cy="209929"/>
-              </a:xfrm>
-              <a:prstGeom prst="rect">
-                <a:avLst/>
-              </a:prstGeom>
-              <a:noFill/>
-            </p:spPr>
-            <p:txBody>
-              <a:bodyPr wrap="square" lIns="0" tIns="0" rIns="0" bIns="0" rtlCol="0">
-                <a:spAutoFit/>
-              </a:bodyPr>
-              <a:lstStyle/>
-              <a:p>
-                <a:r>
-                  <a:rPr lang="en-US" sz="1364" dirty="0">
-                    <a:latin typeface="Arial" panose="020B0604020202020204" pitchFamily="34" charset="0"/>
-                    <a:cs typeface="Arial" panose="020B0604020202020204" pitchFamily="34" charset="0"/>
-                  </a:rPr>
-                  <a:t>**</a:t>
-                </a:r>
-              </a:p>
-            </p:txBody>
-          </p:sp>
-          <p:sp>
-            <p:nvSpPr>
-              <p:cNvPr id="20" name="TextBox 19">
-                <a:extLst>
-                  <a:ext uri="{FF2B5EF4-FFF2-40B4-BE49-F238E27FC236}">
-                    <a16:creationId xmlns:a16="http://schemas.microsoft.com/office/drawing/2014/main" id="{645F2607-7164-19A7-14A6-C46EEC2CA452}"/>
-                  </a:ext>
-                </a:extLst>
-              </p:cNvPr>
-              <p:cNvSpPr txBox="1"/>
-              <p:nvPr/>
-            </p:nvSpPr>
-            <p:spPr>
-              <a:xfrm>
-                <a:off x="7523017" y="6206948"/>
-                <a:ext cx="209419" cy="209929"/>
-              </a:xfrm>
-              <a:prstGeom prst="rect">
-                <a:avLst/>
-              </a:prstGeom>
-              <a:noFill/>
-            </p:spPr>
-            <p:txBody>
-              <a:bodyPr wrap="square" lIns="0" tIns="0" rIns="0" bIns="0" rtlCol="0">
-                <a:spAutoFit/>
-              </a:bodyPr>
-              <a:lstStyle/>
-              <a:p>
-                <a:r>
-                  <a:rPr lang="en-US" sz="1364" dirty="0">
-                    <a:latin typeface="Arial" panose="020B0604020202020204" pitchFamily="34" charset="0"/>
-                    <a:cs typeface="Arial" panose="020B0604020202020204" pitchFamily="34" charset="0"/>
-                  </a:rPr>
-                  <a:t>***</a:t>
-                </a:r>
-              </a:p>
-            </p:txBody>
-          </p:sp>
-          <p:sp>
-            <p:nvSpPr>
-              <p:cNvPr id="21" name="TextBox 20">
-                <a:extLst>
-                  <a:ext uri="{FF2B5EF4-FFF2-40B4-BE49-F238E27FC236}">
-                    <a16:creationId xmlns:a16="http://schemas.microsoft.com/office/drawing/2014/main" id="{FCEB9CBC-BC55-5A9A-ED32-9CB2C0C14223}"/>
-                  </a:ext>
-                </a:extLst>
-              </p:cNvPr>
-              <p:cNvSpPr txBox="1"/>
-              <p:nvPr/>
-            </p:nvSpPr>
-            <p:spPr>
-              <a:xfrm>
-                <a:off x="5714441" y="7214148"/>
-                <a:ext cx="209419" cy="209929"/>
-              </a:xfrm>
-              <a:prstGeom prst="rect">
-                <a:avLst/>
-              </a:prstGeom>
-              <a:noFill/>
-            </p:spPr>
-            <p:txBody>
-              <a:bodyPr wrap="square" lIns="0" tIns="0" rIns="0" bIns="0" rtlCol="0">
-                <a:spAutoFit/>
-              </a:bodyPr>
-              <a:lstStyle/>
-              <a:p>
-                <a:r>
-                  <a:rPr lang="en-US" sz="1364" dirty="0">
-                    <a:latin typeface="Arial" panose="020B0604020202020204" pitchFamily="34" charset="0"/>
-                    <a:cs typeface="Arial" panose="020B0604020202020204" pitchFamily="34" charset="0"/>
-                  </a:rPr>
-                  <a:t>***</a:t>
-                </a:r>
-              </a:p>
-            </p:txBody>
-          </p:sp>
-          <p:sp>
-            <p:nvSpPr>
-              <p:cNvPr id="22" name="TextBox 21">
-                <a:extLst>
-                  <a:ext uri="{FF2B5EF4-FFF2-40B4-BE49-F238E27FC236}">
-                    <a16:creationId xmlns:a16="http://schemas.microsoft.com/office/drawing/2014/main" id="{1A2592EB-5215-FC07-C6F0-BF059CC6E6AD}"/>
-                  </a:ext>
-                </a:extLst>
-              </p:cNvPr>
-              <p:cNvSpPr txBox="1"/>
-              <p:nvPr/>
-            </p:nvSpPr>
-            <p:spPr>
-              <a:xfrm>
-                <a:off x="8132440" y="6663199"/>
-                <a:ext cx="209419" cy="209929"/>
-              </a:xfrm>
-              <a:prstGeom prst="rect">
-                <a:avLst/>
-              </a:prstGeom>
-              <a:noFill/>
-            </p:spPr>
-            <p:txBody>
-              <a:bodyPr wrap="square" lIns="0" tIns="0" rIns="0" bIns="0" rtlCol="0">
-                <a:spAutoFit/>
-              </a:bodyPr>
-              <a:lstStyle/>
-              <a:p>
-                <a:r>
-                  <a:rPr lang="en-US" sz="1364" dirty="0">
-                    <a:latin typeface="Arial" panose="020B0604020202020204" pitchFamily="34" charset="0"/>
-                    <a:cs typeface="Arial" panose="020B0604020202020204" pitchFamily="34" charset="0"/>
-                  </a:rPr>
-                  <a:t>***</a:t>
-                </a:r>
-              </a:p>
-            </p:txBody>
-          </p:sp>
-          <p:sp>
-            <p:nvSpPr>
-              <p:cNvPr id="23" name="TextBox 22">
-                <a:extLst>
-                  <a:ext uri="{FF2B5EF4-FFF2-40B4-BE49-F238E27FC236}">
-                    <a16:creationId xmlns:a16="http://schemas.microsoft.com/office/drawing/2014/main" id="{410B08E0-5328-73DD-1BC2-6AD7FDB897F0}"/>
-                  </a:ext>
-                </a:extLst>
-              </p:cNvPr>
-              <p:cNvSpPr txBox="1"/>
-              <p:nvPr/>
-            </p:nvSpPr>
-            <p:spPr>
-              <a:xfrm>
-                <a:off x="6920229" y="6648070"/>
-                <a:ext cx="209419" cy="209929"/>
-              </a:xfrm>
-              <a:prstGeom prst="rect">
-                <a:avLst/>
-              </a:prstGeom>
-              <a:noFill/>
-            </p:spPr>
-            <p:txBody>
-              <a:bodyPr wrap="square" lIns="0" tIns="0" rIns="0" bIns="0" rtlCol="0">
-                <a:spAutoFit/>
-              </a:bodyPr>
-              <a:lstStyle/>
-              <a:p>
-                <a:r>
-                  <a:rPr lang="en-US" sz="1364" dirty="0">
-                    <a:latin typeface="Arial" panose="020B0604020202020204" pitchFamily="34" charset="0"/>
-                    <a:cs typeface="Arial" panose="020B0604020202020204" pitchFamily="34" charset="0"/>
-                  </a:rPr>
-                  <a:t>***</a:t>
-                </a:r>
-              </a:p>
-            </p:txBody>
-          </p:sp>
-        </p:grpSp>
-      </p:grpSp>
+          <a:prstGeom prst="rect">
+            <a:avLst/>
+          </a:prstGeom>
+          <a:ln>
+            <a:solidFill>
+              <a:schemeClr val="tx1"/>
+            </a:solidFill>
+          </a:ln>
+        </p:spPr>
+      </p:pic>
+      <p:pic>
+        <p:nvPicPr>
+          <p:cNvPr id="5" name="Picture 4">
+            <a:extLst>
+              <a:ext uri="{FF2B5EF4-FFF2-40B4-BE49-F238E27FC236}">
+                <a16:creationId xmlns:a16="http://schemas.microsoft.com/office/drawing/2014/main" id="{4A5E02E6-2F94-948A-D365-515D285A5274}"/>
+              </a:ext>
+            </a:extLst>
+          </p:cNvPr>
+          <p:cNvPicPr>
+            <a:picLocks noChangeAspect="1"/>
+          </p:cNvPicPr>
+          <p:nvPr/>
+        </p:nvPicPr>
+        <p:blipFill>
+          <a:blip r:embed="rId3">
+            <a:extLst>
+              <a:ext uri="{28A0092B-C50C-407E-A947-70E740481C1C}">
+                <a14:useLocalDpi xmlns:a14="http://schemas.microsoft.com/office/drawing/2010/main" val="0"/>
+              </a:ext>
+            </a:extLst>
+          </a:blip>
+          <a:stretch>
+            <a:fillRect/>
+          </a:stretch>
+        </p:blipFill>
+        <p:spPr>
+          <a:xfrm>
+            <a:off x="914400" y="0"/>
+            <a:ext cx="5943600" cy="6939532"/>
+          </a:xfrm>
+          <a:prstGeom prst="rect">
+            <a:avLst/>
+          </a:prstGeom>
+          <a:ln>
+            <a:solidFill>
+              <a:schemeClr val="tx1"/>
+            </a:solidFill>
+          </a:ln>
+        </p:spPr>
+      </p:pic>
+      <p:sp>
+        <p:nvSpPr>
+          <p:cNvPr id="16" name="TextBox 15">
+            <a:extLst>
+              <a:ext uri="{FF2B5EF4-FFF2-40B4-BE49-F238E27FC236}">
+                <a16:creationId xmlns:a16="http://schemas.microsoft.com/office/drawing/2014/main" id="{78762A43-995E-60B4-835D-4D2F126C6D06}"/>
+              </a:ext>
+            </a:extLst>
+          </p:cNvPr>
+          <p:cNvSpPr txBox="1"/>
+          <p:nvPr/>
+        </p:nvSpPr>
+        <p:spPr>
+          <a:xfrm>
+            <a:off x="914400" y="0"/>
+            <a:ext cx="176405" cy="338875"/>
+          </a:xfrm>
+          <a:prstGeom prst="rect">
+            <a:avLst/>
+          </a:prstGeom>
+          <a:noFill/>
+          <a:ln w="12700">
+            <a:solidFill>
+              <a:schemeClr val="tx1"/>
+            </a:solidFill>
+          </a:ln>
+        </p:spPr>
+        <p:txBody>
+          <a:bodyPr wrap="square" rtlCol="0">
+            <a:spAutoFit/>
+          </a:bodyPr>
+          <a:lstStyle/>
+          <a:p>
+            <a:pPr algn="ctr"/>
+            <a:r>
+              <a:rPr lang="en-US" sz="1602" b="1" dirty="0">
+                <a:latin typeface="Arial" panose="020B0604020202020204" pitchFamily="34" charset="0"/>
+                <a:cs typeface="Arial" panose="020B0604020202020204" pitchFamily="34" charset="0"/>
+              </a:rPr>
+              <a:t>A</a:t>
+            </a:r>
+          </a:p>
+        </p:txBody>
+      </p:sp>
+      <p:sp>
+        <p:nvSpPr>
+          <p:cNvPr id="17" name="TextBox 16">
+            <a:extLst>
+              <a:ext uri="{FF2B5EF4-FFF2-40B4-BE49-F238E27FC236}">
+                <a16:creationId xmlns:a16="http://schemas.microsoft.com/office/drawing/2014/main" id="{3784CAE7-B813-0BBD-E932-3A64CD2008DF}"/>
+              </a:ext>
+            </a:extLst>
+          </p:cNvPr>
+          <p:cNvSpPr txBox="1"/>
+          <p:nvPr/>
+        </p:nvSpPr>
+        <p:spPr>
+          <a:xfrm>
+            <a:off x="914399" y="6939532"/>
+            <a:ext cx="176405" cy="338875"/>
+          </a:xfrm>
+          <a:prstGeom prst="rect">
+            <a:avLst/>
+          </a:prstGeom>
+          <a:noFill/>
+          <a:ln w="12700">
+            <a:solidFill>
+              <a:schemeClr val="tx1"/>
+            </a:solidFill>
+          </a:ln>
+        </p:spPr>
+        <p:txBody>
+          <a:bodyPr wrap="square" rtlCol="0">
+            <a:spAutoFit/>
+          </a:bodyPr>
+          <a:lstStyle/>
+          <a:p>
+            <a:pPr algn="ctr"/>
+            <a:r>
+              <a:rPr lang="en-US" sz="1602" b="1" dirty="0">
+                <a:latin typeface="Arial" panose="020B0604020202020204" pitchFamily="34" charset="0"/>
+                <a:cs typeface="Arial" panose="020B0604020202020204" pitchFamily="34" charset="0"/>
+              </a:rPr>
+              <a:t>B</a:t>
+            </a:r>
+          </a:p>
+        </p:txBody>
+      </p:sp>
+      <p:sp>
+        <p:nvSpPr>
+          <p:cNvPr id="19" name="TextBox 18">
+            <a:extLst>
+              <a:ext uri="{FF2B5EF4-FFF2-40B4-BE49-F238E27FC236}">
+                <a16:creationId xmlns:a16="http://schemas.microsoft.com/office/drawing/2014/main" id="{0E592B03-AD14-BB32-06DA-33307CDFA942}"/>
+              </a:ext>
+            </a:extLst>
+          </p:cNvPr>
+          <p:cNvSpPr txBox="1"/>
+          <p:nvPr/>
+        </p:nvSpPr>
+        <p:spPr>
+          <a:xfrm>
+            <a:off x="1717355" y="7857570"/>
+            <a:ext cx="235715" cy="307905"/>
+          </a:xfrm>
+          <a:prstGeom prst="rect">
+            <a:avLst/>
+          </a:prstGeom>
+          <a:noFill/>
+        </p:spPr>
+        <p:txBody>
+          <a:bodyPr wrap="square" lIns="0" tIns="0" rIns="0" bIns="0" rtlCol="0">
+            <a:spAutoFit/>
+          </a:bodyPr>
+          <a:lstStyle/>
+          <a:p>
+            <a:r>
+              <a:rPr lang="en-US" sz="2001" dirty="0">
+                <a:latin typeface="Arial" panose="020B0604020202020204" pitchFamily="34" charset="0"/>
+                <a:cs typeface="Arial" panose="020B0604020202020204" pitchFamily="34" charset="0"/>
+              </a:rPr>
+              <a:t>**</a:t>
+            </a:r>
+          </a:p>
+        </p:txBody>
+      </p:sp>
+      <p:sp>
+        <p:nvSpPr>
+          <p:cNvPr id="20" name="TextBox 19">
+            <a:extLst>
+              <a:ext uri="{FF2B5EF4-FFF2-40B4-BE49-F238E27FC236}">
+                <a16:creationId xmlns:a16="http://schemas.microsoft.com/office/drawing/2014/main" id="{645F2607-7164-19A7-14A6-C46EEC2CA452}"/>
+              </a:ext>
+            </a:extLst>
+          </p:cNvPr>
+          <p:cNvSpPr txBox="1"/>
+          <p:nvPr/>
+        </p:nvSpPr>
+        <p:spPr>
+          <a:xfrm>
+            <a:off x="5593317" y="7397371"/>
+            <a:ext cx="430695" cy="307905"/>
+          </a:xfrm>
+          <a:prstGeom prst="rect">
+            <a:avLst/>
+          </a:prstGeom>
+          <a:noFill/>
+        </p:spPr>
+        <p:txBody>
+          <a:bodyPr wrap="square" lIns="0" tIns="0" rIns="0" bIns="0" rtlCol="0">
+            <a:spAutoFit/>
+          </a:bodyPr>
+          <a:lstStyle/>
+          <a:p>
+            <a:r>
+              <a:rPr lang="en-US" sz="2001" dirty="0">
+                <a:latin typeface="Arial" panose="020B0604020202020204" pitchFamily="34" charset="0"/>
+                <a:cs typeface="Arial" panose="020B0604020202020204" pitchFamily="34" charset="0"/>
+              </a:rPr>
+              <a:t>***</a:t>
+            </a:r>
+          </a:p>
+        </p:txBody>
+      </p:sp>
+      <p:sp>
+        <p:nvSpPr>
+          <p:cNvPr id="21" name="TextBox 20">
+            <a:extLst>
+              <a:ext uri="{FF2B5EF4-FFF2-40B4-BE49-F238E27FC236}">
+                <a16:creationId xmlns:a16="http://schemas.microsoft.com/office/drawing/2014/main" id="{FCEB9CBC-BC55-5A9A-ED32-9CB2C0C14223}"/>
+              </a:ext>
+            </a:extLst>
+          </p:cNvPr>
+          <p:cNvSpPr txBox="1"/>
+          <p:nvPr/>
+        </p:nvSpPr>
+        <p:spPr>
+          <a:xfrm>
+            <a:off x="3640356" y="8471021"/>
+            <a:ext cx="412412" cy="307905"/>
+          </a:xfrm>
+          <a:prstGeom prst="rect">
+            <a:avLst/>
+          </a:prstGeom>
+          <a:noFill/>
+        </p:spPr>
+        <p:txBody>
+          <a:bodyPr wrap="square" lIns="0" tIns="0" rIns="0" bIns="0" rtlCol="0">
+            <a:spAutoFit/>
+          </a:bodyPr>
+          <a:lstStyle/>
+          <a:p>
+            <a:r>
+              <a:rPr lang="en-US" sz="2001" dirty="0">
+                <a:latin typeface="Arial" panose="020B0604020202020204" pitchFamily="34" charset="0"/>
+                <a:cs typeface="Arial" panose="020B0604020202020204" pitchFamily="34" charset="0"/>
+              </a:rPr>
+              <a:t>***</a:t>
+            </a:r>
+          </a:p>
+        </p:txBody>
+      </p:sp>
+      <p:sp>
+        <p:nvSpPr>
+          <p:cNvPr id="22" name="TextBox 21">
+            <a:extLst>
+              <a:ext uri="{FF2B5EF4-FFF2-40B4-BE49-F238E27FC236}">
+                <a16:creationId xmlns:a16="http://schemas.microsoft.com/office/drawing/2014/main" id="{1A2592EB-5215-FC07-C6F0-BF059CC6E6AD}"/>
+              </a:ext>
+            </a:extLst>
+          </p:cNvPr>
+          <p:cNvSpPr txBox="1"/>
+          <p:nvPr/>
+        </p:nvSpPr>
+        <p:spPr>
+          <a:xfrm>
+            <a:off x="6247098" y="7890306"/>
+            <a:ext cx="351287" cy="307905"/>
+          </a:xfrm>
+          <a:prstGeom prst="rect">
+            <a:avLst/>
+          </a:prstGeom>
+          <a:noFill/>
+        </p:spPr>
+        <p:txBody>
+          <a:bodyPr wrap="square" lIns="0" tIns="0" rIns="0" bIns="0" rtlCol="0">
+            <a:spAutoFit/>
+          </a:bodyPr>
+          <a:lstStyle/>
+          <a:p>
+            <a:r>
+              <a:rPr lang="en-US" sz="2001" dirty="0">
+                <a:latin typeface="Arial" panose="020B0604020202020204" pitchFamily="34" charset="0"/>
+                <a:cs typeface="Arial" panose="020B0604020202020204" pitchFamily="34" charset="0"/>
+              </a:rPr>
+              <a:t>***</a:t>
+            </a:r>
+          </a:p>
+        </p:txBody>
+      </p:sp>
+      <p:sp>
+        <p:nvSpPr>
+          <p:cNvPr id="23" name="TextBox 22">
+            <a:extLst>
+              <a:ext uri="{FF2B5EF4-FFF2-40B4-BE49-F238E27FC236}">
+                <a16:creationId xmlns:a16="http://schemas.microsoft.com/office/drawing/2014/main" id="{410B08E0-5328-73DD-1BC2-6AD7FDB897F0}"/>
+              </a:ext>
+            </a:extLst>
+          </p:cNvPr>
+          <p:cNvSpPr txBox="1"/>
+          <p:nvPr/>
+        </p:nvSpPr>
+        <p:spPr>
+          <a:xfrm>
+            <a:off x="4960790" y="7857570"/>
+            <a:ext cx="318836" cy="307905"/>
+          </a:xfrm>
+          <a:prstGeom prst="rect">
+            <a:avLst/>
+          </a:prstGeom>
+          <a:noFill/>
+        </p:spPr>
+        <p:txBody>
+          <a:bodyPr wrap="square" lIns="0" tIns="0" rIns="0" bIns="0" rtlCol="0">
+            <a:spAutoFit/>
+          </a:bodyPr>
+          <a:lstStyle/>
+          <a:p>
+            <a:r>
+              <a:rPr lang="en-US" sz="2001" dirty="0">
+                <a:latin typeface="Arial" panose="020B0604020202020204" pitchFamily="34" charset="0"/>
+                <a:cs typeface="Arial" panose="020B0604020202020204" pitchFamily="34" charset="0"/>
+              </a:rPr>
+              <a:t>***</a:t>
+            </a:r>
+          </a:p>
+        </p:txBody>
+      </p:sp>
     </p:spTree>
     <p:extLst>
       <p:ext uri="{BB962C8B-B14F-4D97-AF65-F5344CB8AC3E}">
@@ -5417,6 +5002,419 @@
       </p:grpSpPr>
       <p:grpSp>
         <p:nvGrpSpPr>
+          <p:cNvPr id="12" name="Group 11">
+            <a:extLst>
+              <a:ext uri="{FF2B5EF4-FFF2-40B4-BE49-F238E27FC236}">
+                <a16:creationId xmlns:a16="http://schemas.microsoft.com/office/drawing/2014/main" id="{FE490F20-00AE-EEFF-DC3A-F23F851A3F03}"/>
+              </a:ext>
+            </a:extLst>
+          </p:cNvPr>
+          <p:cNvGrpSpPr>
+            <a:grpSpLocks noChangeAspect="1"/>
+          </p:cNvGrpSpPr>
+          <p:nvPr/>
+        </p:nvGrpSpPr>
+        <p:grpSpPr>
+          <a:xfrm>
+            <a:off x="914400" y="914400"/>
+            <a:ext cx="5109890" cy="8229600"/>
+            <a:chOff x="914400" y="258417"/>
+            <a:chExt cx="5943600" cy="9572310"/>
+          </a:xfrm>
+        </p:grpSpPr>
+        <p:pic>
+          <p:nvPicPr>
+            <p:cNvPr id="7" name="Picture 6">
+              <a:extLst>
+                <a:ext uri="{FF2B5EF4-FFF2-40B4-BE49-F238E27FC236}">
+                  <a16:creationId xmlns:a16="http://schemas.microsoft.com/office/drawing/2014/main" id="{63BB9124-4A96-A65F-A716-8EBFCCD99A0F}"/>
+                </a:ext>
+              </a:extLst>
+            </p:cNvPr>
+            <p:cNvPicPr>
+              <a:picLocks noChangeAspect="1"/>
+            </p:cNvPicPr>
+            <p:nvPr/>
+          </p:nvPicPr>
+          <p:blipFill>
+            <a:blip r:embed="rId2">
+              <a:extLst>
+                <a:ext uri="{28A0092B-C50C-407E-A947-70E740481C1C}">
+                  <a14:useLocalDpi xmlns:a14="http://schemas.microsoft.com/office/drawing/2010/main" val="0"/>
+                </a:ext>
+              </a:extLst>
+            </a:blip>
+            <a:stretch>
+              <a:fillRect/>
+            </a:stretch>
+          </p:blipFill>
+          <p:spPr>
+            <a:xfrm>
+              <a:off x="914400" y="258417"/>
+              <a:ext cx="5943600" cy="7286310"/>
+            </a:xfrm>
+            <a:prstGeom prst="rect">
+              <a:avLst/>
+            </a:prstGeom>
+            <a:ln>
+              <a:solidFill>
+                <a:schemeClr val="tx1"/>
+              </a:solidFill>
+            </a:ln>
+          </p:spPr>
+        </p:pic>
+        <p:pic>
+          <p:nvPicPr>
+            <p:cNvPr id="11" name="Picture 10">
+              <a:extLst>
+                <a:ext uri="{FF2B5EF4-FFF2-40B4-BE49-F238E27FC236}">
+                  <a16:creationId xmlns:a16="http://schemas.microsoft.com/office/drawing/2014/main" id="{CD34FD73-AFE4-A4DA-58A4-C519A15B9BE0}"/>
+                </a:ext>
+              </a:extLst>
+            </p:cNvPr>
+            <p:cNvPicPr>
+              <a:picLocks noChangeAspect="1"/>
+            </p:cNvPicPr>
+            <p:nvPr/>
+          </p:nvPicPr>
+          <p:blipFill>
+            <a:blip r:embed="rId3">
+              <a:extLst>
+                <a:ext uri="{28A0092B-C50C-407E-A947-70E740481C1C}">
+                  <a14:useLocalDpi xmlns:a14="http://schemas.microsoft.com/office/drawing/2010/main" val="0"/>
+                </a:ext>
+              </a:extLst>
+            </a:blip>
+            <a:stretch>
+              <a:fillRect/>
+            </a:stretch>
+          </p:blipFill>
+          <p:spPr>
+            <a:xfrm>
+              <a:off x="914400" y="7544727"/>
+              <a:ext cx="5943600" cy="2286000"/>
+            </a:xfrm>
+            <a:prstGeom prst="rect">
+              <a:avLst/>
+            </a:prstGeom>
+            <a:ln>
+              <a:solidFill>
+                <a:schemeClr val="tx1"/>
+              </a:solidFill>
+            </a:ln>
+          </p:spPr>
+        </p:pic>
+      </p:grpSp>
+      <p:sp>
+        <p:nvSpPr>
+          <p:cNvPr id="14" name="TextBox 13">
+            <a:extLst>
+              <a:ext uri="{FF2B5EF4-FFF2-40B4-BE49-F238E27FC236}">
+                <a16:creationId xmlns:a16="http://schemas.microsoft.com/office/drawing/2014/main" id="{BAF968E4-C831-CA67-D592-C848A1461A34}"/>
+              </a:ext>
+            </a:extLst>
+          </p:cNvPr>
+          <p:cNvSpPr txBox="1"/>
+          <p:nvPr/>
+        </p:nvSpPr>
+        <p:spPr>
+          <a:xfrm>
+            <a:off x="914399" y="914400"/>
+            <a:ext cx="176405" cy="338875"/>
+          </a:xfrm>
+          <a:prstGeom prst="rect">
+            <a:avLst/>
+          </a:prstGeom>
+          <a:noFill/>
+          <a:ln w="12700">
+            <a:solidFill>
+              <a:schemeClr val="tx1"/>
+            </a:solidFill>
+          </a:ln>
+        </p:spPr>
+        <p:txBody>
+          <a:bodyPr wrap="square" rtlCol="0">
+            <a:spAutoFit/>
+          </a:bodyPr>
+          <a:lstStyle/>
+          <a:p>
+            <a:pPr algn="ctr"/>
+            <a:r>
+              <a:rPr lang="en-US" sz="1602" b="1" dirty="0">
+                <a:latin typeface="Arial" panose="020B0604020202020204" pitchFamily="34" charset="0"/>
+                <a:cs typeface="Arial" panose="020B0604020202020204" pitchFamily="34" charset="0"/>
+              </a:rPr>
+              <a:t>A</a:t>
+            </a:r>
+          </a:p>
+        </p:txBody>
+      </p:sp>
+      <p:sp>
+        <p:nvSpPr>
+          <p:cNvPr id="16" name="TextBox 15">
+            <a:extLst>
+              <a:ext uri="{FF2B5EF4-FFF2-40B4-BE49-F238E27FC236}">
+                <a16:creationId xmlns:a16="http://schemas.microsoft.com/office/drawing/2014/main" id="{3A4AAC19-ACAC-FCF9-A7FC-1A754B81114B}"/>
+              </a:ext>
+            </a:extLst>
+          </p:cNvPr>
+          <p:cNvSpPr txBox="1"/>
+          <p:nvPr/>
+        </p:nvSpPr>
+        <p:spPr>
+          <a:xfrm>
+            <a:off x="914399" y="7178658"/>
+            <a:ext cx="176405" cy="338875"/>
+          </a:xfrm>
+          <a:prstGeom prst="rect">
+            <a:avLst/>
+          </a:prstGeom>
+          <a:noFill/>
+          <a:ln w="12700">
+            <a:solidFill>
+              <a:schemeClr val="tx1"/>
+            </a:solidFill>
+          </a:ln>
+        </p:spPr>
+        <p:txBody>
+          <a:bodyPr wrap="square" rtlCol="0">
+            <a:spAutoFit/>
+          </a:bodyPr>
+          <a:lstStyle/>
+          <a:p>
+            <a:pPr algn="ctr"/>
+            <a:r>
+              <a:rPr lang="en-US" sz="1602" b="1" dirty="0">
+                <a:latin typeface="Arial" panose="020B0604020202020204" pitchFamily="34" charset="0"/>
+                <a:cs typeface="Arial" panose="020B0604020202020204" pitchFamily="34" charset="0"/>
+              </a:rPr>
+              <a:t>B</a:t>
+            </a:r>
+          </a:p>
+        </p:txBody>
+      </p:sp>
+      <p:sp>
+        <p:nvSpPr>
+          <p:cNvPr id="18" name="TextBox 17">
+            <a:extLst>
+              <a:ext uri="{FF2B5EF4-FFF2-40B4-BE49-F238E27FC236}">
+                <a16:creationId xmlns:a16="http://schemas.microsoft.com/office/drawing/2014/main" id="{DA0EAA70-E629-7F43-CDE0-C7AA3DAA0E16}"/>
+              </a:ext>
+            </a:extLst>
+          </p:cNvPr>
+          <p:cNvSpPr txBox="1"/>
+          <p:nvPr/>
+        </p:nvSpPr>
+        <p:spPr>
+          <a:xfrm>
+            <a:off x="1630252" y="8068996"/>
+            <a:ext cx="235715" cy="184666"/>
+          </a:xfrm>
+          <a:prstGeom prst="rect">
+            <a:avLst/>
+          </a:prstGeom>
+          <a:noFill/>
+        </p:spPr>
+        <p:txBody>
+          <a:bodyPr wrap="square" lIns="0" tIns="0" rIns="0" bIns="0" rtlCol="0">
+            <a:spAutoFit/>
+          </a:bodyPr>
+          <a:lstStyle/>
+          <a:p>
+            <a:r>
+              <a:rPr lang="en-US" sz="1200" dirty="0">
+                <a:latin typeface="Arial" panose="020B0604020202020204" pitchFamily="34" charset="0"/>
+                <a:cs typeface="Arial" panose="020B0604020202020204" pitchFamily="34" charset="0"/>
+              </a:rPr>
+              <a:t>**</a:t>
+            </a:r>
+          </a:p>
+        </p:txBody>
+      </p:sp>
+      <p:sp>
+        <p:nvSpPr>
+          <p:cNvPr id="20" name="TextBox 19">
+            <a:extLst>
+              <a:ext uri="{FF2B5EF4-FFF2-40B4-BE49-F238E27FC236}">
+                <a16:creationId xmlns:a16="http://schemas.microsoft.com/office/drawing/2014/main" id="{06112CCC-6DB5-861D-14EC-3C43445330F6}"/>
+              </a:ext>
+            </a:extLst>
+          </p:cNvPr>
+          <p:cNvSpPr txBox="1"/>
+          <p:nvPr/>
+        </p:nvSpPr>
+        <p:spPr>
+          <a:xfrm>
+            <a:off x="4974193" y="7649784"/>
+            <a:ext cx="430695" cy="184666"/>
+          </a:xfrm>
+          <a:prstGeom prst="rect">
+            <a:avLst/>
+          </a:prstGeom>
+          <a:noFill/>
+        </p:spPr>
+        <p:txBody>
+          <a:bodyPr wrap="square" lIns="0" tIns="0" rIns="0" bIns="0" rtlCol="0">
+            <a:spAutoFit/>
+          </a:bodyPr>
+          <a:lstStyle/>
+          <a:p>
+            <a:r>
+              <a:rPr lang="en-US" sz="1200" dirty="0">
+                <a:latin typeface="Arial" panose="020B0604020202020204" pitchFamily="34" charset="0"/>
+                <a:cs typeface="Arial" panose="020B0604020202020204" pitchFamily="34" charset="0"/>
+              </a:rPr>
+              <a:t>***</a:t>
+            </a:r>
+          </a:p>
+        </p:txBody>
+      </p:sp>
+      <p:sp>
+        <p:nvSpPr>
+          <p:cNvPr id="22" name="TextBox 21">
+            <a:extLst>
+              <a:ext uri="{FF2B5EF4-FFF2-40B4-BE49-F238E27FC236}">
+                <a16:creationId xmlns:a16="http://schemas.microsoft.com/office/drawing/2014/main" id="{A66B252E-AF28-181D-4E2D-5986EFFD2192}"/>
+              </a:ext>
+            </a:extLst>
+          </p:cNvPr>
+          <p:cNvSpPr txBox="1"/>
+          <p:nvPr/>
+        </p:nvSpPr>
+        <p:spPr>
+          <a:xfrm>
+            <a:off x="3297456" y="8575796"/>
+            <a:ext cx="412412" cy="184666"/>
+          </a:xfrm>
+          <a:prstGeom prst="rect">
+            <a:avLst/>
+          </a:prstGeom>
+          <a:noFill/>
+        </p:spPr>
+        <p:txBody>
+          <a:bodyPr wrap="square" lIns="0" tIns="0" rIns="0" bIns="0" rtlCol="0">
+            <a:spAutoFit/>
+          </a:bodyPr>
+          <a:lstStyle/>
+          <a:p>
+            <a:r>
+              <a:rPr lang="en-US" sz="1200" dirty="0">
+                <a:latin typeface="Arial" panose="020B0604020202020204" pitchFamily="34" charset="0"/>
+                <a:cs typeface="Arial" panose="020B0604020202020204" pitchFamily="34" charset="0"/>
+              </a:rPr>
+              <a:t>***</a:t>
+            </a:r>
+          </a:p>
+        </p:txBody>
+      </p:sp>
+      <p:sp>
+        <p:nvSpPr>
+          <p:cNvPr id="24" name="TextBox 23">
+            <a:extLst>
+              <a:ext uri="{FF2B5EF4-FFF2-40B4-BE49-F238E27FC236}">
+                <a16:creationId xmlns:a16="http://schemas.microsoft.com/office/drawing/2014/main" id="{FD3C32A5-925C-3234-F9F0-1B21E52E60E2}"/>
+              </a:ext>
+            </a:extLst>
+          </p:cNvPr>
+          <p:cNvSpPr txBox="1"/>
+          <p:nvPr/>
+        </p:nvSpPr>
+        <p:spPr>
+          <a:xfrm>
+            <a:off x="5537486" y="8068996"/>
+            <a:ext cx="351287" cy="184666"/>
+          </a:xfrm>
+          <a:prstGeom prst="rect">
+            <a:avLst/>
+          </a:prstGeom>
+          <a:noFill/>
+        </p:spPr>
+        <p:txBody>
+          <a:bodyPr wrap="square" lIns="0" tIns="0" rIns="0" bIns="0" rtlCol="0">
+            <a:spAutoFit/>
+          </a:bodyPr>
+          <a:lstStyle/>
+          <a:p>
+            <a:r>
+              <a:rPr lang="en-US" sz="1200" dirty="0">
+                <a:latin typeface="Arial" panose="020B0604020202020204" pitchFamily="34" charset="0"/>
+                <a:cs typeface="Arial" panose="020B0604020202020204" pitchFamily="34" charset="0"/>
+              </a:rPr>
+              <a:t>***</a:t>
+            </a:r>
+          </a:p>
+        </p:txBody>
+      </p:sp>
+      <p:sp>
+        <p:nvSpPr>
+          <p:cNvPr id="26" name="TextBox 25">
+            <a:extLst>
+              <a:ext uri="{FF2B5EF4-FFF2-40B4-BE49-F238E27FC236}">
+                <a16:creationId xmlns:a16="http://schemas.microsoft.com/office/drawing/2014/main" id="{F816624F-0A48-1066-0674-78D41106AAC6}"/>
+              </a:ext>
+            </a:extLst>
+          </p:cNvPr>
+          <p:cNvSpPr txBox="1"/>
+          <p:nvPr/>
+        </p:nvSpPr>
+        <p:spPr>
+          <a:xfrm>
+            <a:off x="4413102" y="8050635"/>
+            <a:ext cx="318836" cy="184666"/>
+          </a:xfrm>
+          <a:prstGeom prst="rect">
+            <a:avLst/>
+          </a:prstGeom>
+          <a:noFill/>
+        </p:spPr>
+        <p:txBody>
+          <a:bodyPr wrap="square" lIns="0" tIns="0" rIns="0" bIns="0" rtlCol="0">
+            <a:spAutoFit/>
+          </a:bodyPr>
+          <a:lstStyle/>
+          <a:p>
+            <a:r>
+              <a:rPr lang="en-US" sz="1200" dirty="0">
+                <a:latin typeface="Arial" panose="020B0604020202020204" pitchFamily="34" charset="0"/>
+                <a:cs typeface="Arial" panose="020B0604020202020204" pitchFamily="34" charset="0"/>
+              </a:rPr>
+              <a:t>***</a:t>
+            </a:r>
+          </a:p>
+        </p:txBody>
+      </p:sp>
+    </p:spTree>
+    <p:extLst>
+      <p:ext uri="{BB962C8B-B14F-4D97-AF65-F5344CB8AC3E}">
+        <p14:creationId xmlns:p14="http://schemas.microsoft.com/office/powerpoint/2010/main" val="547704271"/>
+      </p:ext>
+    </p:extLst>
+  </p:cSld>
+  <p:clrMapOvr>
+    <a:masterClrMapping/>
+  </p:clrMapOvr>
+</p:sld>
+</file>
+
+<file path=ppt/slides/slide6.xml><?xml version="1.0" encoding="utf-8"?>
+<p:sld xmlns:a="http://schemas.openxmlformats.org/drawingml/2006/main" xmlns:r="http://schemas.openxmlformats.org/officeDocument/2006/relationships" xmlns:p="http://schemas.openxmlformats.org/presentationml/2006/main">
+  <p:cSld>
+    <p:spTree>
+      <p:nvGrpSpPr>
+        <p:cNvPr id="1" name=""/>
+        <p:cNvGrpSpPr/>
+        <p:nvPr/>
+      </p:nvGrpSpPr>
+      <p:grpSpPr>
+        <a:xfrm>
+          <a:off x="0" y="0"/>
+          <a:ext cx="0" cy="0"/>
+          <a:chOff x="0" y="0"/>
+          <a:chExt cx="0" cy="0"/>
+        </a:xfrm>
+      </p:grpSpPr>
+      <p:grpSp>
+        <p:nvGrpSpPr>
           <p:cNvPr id="8" name="Group 7">
             <a:extLst>
               <a:ext uri="{FF2B5EF4-FFF2-40B4-BE49-F238E27FC236}">
@@ -5429,8 +5427,8 @@
         </p:nvGrpSpPr>
         <p:grpSpPr>
           <a:xfrm>
-            <a:off x="4537367" y="241941"/>
-            <a:ext cx="3117273" cy="6234548"/>
+            <a:off x="1600206" y="354847"/>
+            <a:ext cx="4572000" cy="9144004"/>
             <a:chOff x="3810000" y="354842"/>
             <a:chExt cx="4572000" cy="9144000"/>
           </a:xfrm>
@@ -5520,7 +5518,7 @@
           <p:spPr>
             <a:xfrm>
               <a:off x="3810000" y="354842"/>
-              <a:ext cx="229863" cy="381908"/>
+              <a:ext cx="229863" cy="338875"/>
             </a:xfrm>
             <a:prstGeom prst="rect">
               <a:avLst/>
@@ -5540,7 +5538,7 @@
             <a:p>
               <a:pPr algn="ctr"/>
               <a:r>
-                <a:rPr lang="en-US" sz="1092" b="1" dirty="0">
+                <a:rPr lang="en-US" sz="1602" b="1" dirty="0">
                   <a:latin typeface="Arial" panose="020B0604020202020204" pitchFamily="34" charset="0"/>
                   <a:cs typeface="Arial" panose="020B0604020202020204" pitchFamily="34" charset="0"/>
                 </a:rPr>
@@ -5564,7 +5562,7 @@
           <p:spPr>
             <a:xfrm>
               <a:off x="3810000" y="4926843"/>
-              <a:ext cx="229863" cy="381908"/>
+              <a:ext cx="229863" cy="338875"/>
             </a:xfrm>
             <a:prstGeom prst="rect">
               <a:avLst/>
@@ -5584,7 +5582,7 @@
             <a:p>
               <a:pPr algn="ctr"/>
               <a:r>
-                <a:rPr lang="en-US" sz="1092" b="1" dirty="0">
+                <a:rPr lang="en-US" sz="1602" b="1" dirty="0">
                   <a:latin typeface="Arial" panose="020B0604020202020204" pitchFamily="34" charset="0"/>
                   <a:cs typeface="Arial" panose="020B0604020202020204" pitchFamily="34" charset="0"/>
                 </a:rPr>
@@ -5610,7 +5608,7 @@
 <file path=ppt/theme/theme1.xml><?xml version="1.0" encoding="utf-8"?>
 <a:theme xmlns:a="http://schemas.openxmlformats.org/drawingml/2006/main" name="Office Theme">
   <a:themeElements>
-    <a:clrScheme name="Office">
+    <a:clrScheme name="Office Theme">
       <a:dk1>
         <a:sysClr val="windowText" lastClr="000000"/>
       </a:dk1>
@@ -5648,7 +5646,7 @@
         <a:srgbClr val="96607D"/>
       </a:folHlink>
     </a:clrScheme>
-    <a:fontScheme name="Office">
+    <a:fontScheme name="Office Theme">
       <a:majorFont>
         <a:latin typeface="Aptos Display" panose="02110004020202020204"/>
         <a:ea typeface=""/>
@@ -5754,7 +5752,7 @@
         <a:font script="Tfng" typeface="Ebrima"/>
       </a:minorFont>
     </a:fontScheme>
-    <a:fmtScheme name="Office">
+    <a:fmtScheme name="Office Theme">
       <a:fillStyleLst>
         <a:solidFill>
           <a:schemeClr val="phClr"/>

</xml_diff>